<commit_message>
chore: update default project_name to Assignment in Terraform variables
</commit_message>
<xml_diff>
--- a/Assignment.pptx
+++ b/Assignment.pptx
@@ -5,20 +5,20 @@
     <p:sldMasterId id="2147483648" r:id="rId1"/>
   </p:sldMasterIdLst>
   <p:sldIdLst>
-    <p:sldId id="256" r:id="rId7"/>
-    <p:sldId id="257" r:id="rId8"/>
-    <p:sldId id="258" r:id="rId9"/>
-    <p:sldId id="259" r:id="rId10"/>
-    <p:sldId id="260" r:id="rId11"/>
-    <p:sldId id="261" r:id="rId12"/>
-    <p:sldId id="262" r:id="rId13"/>
-    <p:sldId id="263" r:id="rId14"/>
-    <p:sldId id="264" r:id="rId15"/>
-    <p:sldId id="265" r:id="rId16"/>
-    <p:sldId id="266" r:id="rId17"/>
-    <p:sldId id="267" r:id="rId18"/>
+    <p:sldId id="256" r:id="rId2"/>
+    <p:sldId id="257" r:id="rId3"/>
+    <p:sldId id="258" r:id="rId4"/>
+    <p:sldId id="259" r:id="rId5"/>
+    <p:sldId id="260" r:id="rId6"/>
+    <p:sldId id="261" r:id="rId7"/>
+    <p:sldId id="262" r:id="rId8"/>
+    <p:sldId id="263" r:id="rId9"/>
+    <p:sldId id="264" r:id="rId10"/>
+    <p:sldId id="265" r:id="rId11"/>
+    <p:sldId id="266" r:id="rId12"/>
+    <p:sldId id="267" r:id="rId13"/>
   </p:sldIdLst>
-  <p:sldSz cx="12191695" cy="6858000" type="screen4x3"/>
+  <p:sldSz cx="12192000" cy="6858000"/>
   <p:notesSz cx="6858000" cy="9144000"/>
   <p:defaultTextStyle>
     <a:defPPr>
@@ -115,6 +115,22 @@
       </a:defRPr>
     </a:lvl9pPr>
   </p:defaultTextStyle>
+  <p:extLst>
+    <p:ext uri="{EFAFB233-063F-42B5-8137-9DF3F51BA10A}">
+      <p15:sldGuideLst xmlns:p15="http://schemas.microsoft.com/office/powerpoint/2012/main">
+        <p15:guide id="1" orient="horz" pos="2160">
+          <p15:clr>
+            <a:srgbClr val="A4A3A4"/>
+          </p15:clr>
+        </p15:guide>
+        <p15:guide id="2" pos="2880">
+          <p15:clr>
+            <a:srgbClr val="A4A3A4"/>
+          </p15:clr>
+        </p15:guide>
+      </p15:sldGuideLst>
+    </p:ext>
+  </p:extLst>
 </p:presentation>
 </file>
 
@@ -156,10 +172,9 @@
           <a:lstStyle/>
           <a:p>
             <a:r>
-              <a:rPr lang="en-US" smtClean="0"/>
+              <a:rPr lang="en-US"/>
               <a:t>Click to edit Master title style</a:t>
             </a:r>
-            <a:endParaRPr lang="en-US"/>
           </a:p>
         </p:txBody>
       </p:sp>
@@ -275,10 +290,9 @@
           </a:lstStyle>
           <a:p>
             <a:r>
-              <a:rPr lang="en-US" smtClean="0"/>
+              <a:rPr lang="en-US"/>
               <a:t>Click to edit Master subtitle style</a:t>
             </a:r>
-            <a:endParaRPr lang="en-US"/>
           </a:p>
         </p:txBody>
       </p:sp>
@@ -299,7 +313,7 @@
           <a:p>
             <a:fld id="{5BCAD085-E8A6-8845-BD4E-CB4CCA059FC4}" type="datetimeFigureOut">
               <a:rPr lang="en-US" smtClean="0"/>
-              <a:t>1/27/13</a:t>
+              <a:t>10/29/2026</a:t>
             </a:fld>
             <a:endParaRPr lang="en-US"/>
           </a:p>
@@ -393,10 +407,9 @@
           <a:lstStyle/>
           <a:p>
             <a:r>
-              <a:rPr lang="en-US" smtClean="0"/>
+              <a:rPr lang="en-US"/>
               <a:t>Click to edit Master title style</a:t>
             </a:r>
-            <a:endParaRPr lang="en-US"/>
           </a:p>
         </p:txBody>
       </p:sp>
@@ -417,38 +430,37 @@
           <a:p>
             <a:pPr lvl="0"/>
             <a:r>
-              <a:rPr lang="en-US" smtClean="0"/>
+              <a:rPr lang="en-US"/>
               <a:t>Click to edit Master text styles</a:t>
             </a:r>
           </a:p>
           <a:p>
             <a:pPr lvl="1"/>
             <a:r>
-              <a:rPr lang="en-US" smtClean="0"/>
+              <a:rPr lang="en-US"/>
               <a:t>Second level</a:t>
             </a:r>
           </a:p>
           <a:p>
             <a:pPr lvl="2"/>
             <a:r>
-              <a:rPr lang="en-US" smtClean="0"/>
+              <a:rPr lang="en-US"/>
               <a:t>Third level</a:t>
             </a:r>
           </a:p>
           <a:p>
             <a:pPr lvl="3"/>
             <a:r>
-              <a:rPr lang="en-US" smtClean="0"/>
+              <a:rPr lang="en-US"/>
               <a:t>Fourth level</a:t>
             </a:r>
           </a:p>
           <a:p>
             <a:pPr lvl="4"/>
             <a:r>
-              <a:rPr lang="en-US" smtClean="0"/>
+              <a:rPr lang="en-US"/>
               <a:t>Fifth level</a:t>
             </a:r>
-            <a:endParaRPr lang="en-US"/>
           </a:p>
         </p:txBody>
       </p:sp>
@@ -469,7 +481,7 @@
           <a:p>
             <a:fld id="{5BCAD085-E8A6-8845-BD4E-CB4CCA059FC4}" type="datetimeFigureOut">
               <a:rPr lang="en-US" smtClean="0"/>
-              <a:t>1/27/13</a:t>
+              <a:t>10/29/2026</a:t>
             </a:fld>
             <a:endParaRPr lang="en-US"/>
           </a:p>
@@ -568,10 +580,9 @@
           <a:lstStyle/>
           <a:p>
             <a:r>
-              <a:rPr lang="en-US" smtClean="0"/>
+              <a:rPr lang="en-US"/>
               <a:t>Click to edit Master title style</a:t>
             </a:r>
-            <a:endParaRPr lang="en-US"/>
           </a:p>
         </p:txBody>
       </p:sp>
@@ -597,38 +608,37 @@
           <a:p>
             <a:pPr lvl="0"/>
             <a:r>
-              <a:rPr lang="en-US" smtClean="0"/>
+              <a:rPr lang="en-US"/>
               <a:t>Click to edit Master text styles</a:t>
             </a:r>
           </a:p>
           <a:p>
             <a:pPr lvl="1"/>
             <a:r>
-              <a:rPr lang="en-US" smtClean="0"/>
+              <a:rPr lang="en-US"/>
               <a:t>Second level</a:t>
             </a:r>
           </a:p>
           <a:p>
             <a:pPr lvl="2"/>
             <a:r>
-              <a:rPr lang="en-US" smtClean="0"/>
+              <a:rPr lang="en-US"/>
               <a:t>Third level</a:t>
             </a:r>
           </a:p>
           <a:p>
             <a:pPr lvl="3"/>
             <a:r>
-              <a:rPr lang="en-US" smtClean="0"/>
+              <a:rPr lang="en-US"/>
               <a:t>Fourth level</a:t>
             </a:r>
           </a:p>
           <a:p>
             <a:pPr lvl="4"/>
             <a:r>
-              <a:rPr lang="en-US" smtClean="0"/>
+              <a:rPr lang="en-US"/>
               <a:t>Fifth level</a:t>
             </a:r>
-            <a:endParaRPr lang="en-US"/>
           </a:p>
         </p:txBody>
       </p:sp>
@@ -649,7 +659,7 @@
           <a:p>
             <a:fld id="{5BCAD085-E8A6-8845-BD4E-CB4CCA059FC4}" type="datetimeFigureOut">
               <a:rPr lang="en-US" smtClean="0"/>
-              <a:t>1/27/13</a:t>
+              <a:t>10/29/2026</a:t>
             </a:fld>
             <a:endParaRPr lang="en-US"/>
           </a:p>
@@ -743,10 +753,9 @@
           <a:lstStyle/>
           <a:p>
             <a:r>
-              <a:rPr lang="en-US" smtClean="0"/>
+              <a:rPr lang="en-US"/>
               <a:t>Click to edit Master title style</a:t>
             </a:r>
-            <a:endParaRPr lang="en-US"/>
           </a:p>
         </p:txBody>
       </p:sp>
@@ -767,38 +776,37 @@
           <a:p>
             <a:pPr lvl="0"/>
             <a:r>
-              <a:rPr lang="en-US" smtClean="0"/>
+              <a:rPr lang="en-US"/>
               <a:t>Click to edit Master text styles</a:t>
             </a:r>
           </a:p>
           <a:p>
             <a:pPr lvl="1"/>
             <a:r>
-              <a:rPr lang="en-US" smtClean="0"/>
+              <a:rPr lang="en-US"/>
               <a:t>Second level</a:t>
             </a:r>
           </a:p>
           <a:p>
             <a:pPr lvl="2"/>
             <a:r>
-              <a:rPr lang="en-US" smtClean="0"/>
+              <a:rPr lang="en-US"/>
               <a:t>Third level</a:t>
             </a:r>
           </a:p>
           <a:p>
             <a:pPr lvl="3"/>
             <a:r>
-              <a:rPr lang="en-US" smtClean="0"/>
+              <a:rPr lang="en-US"/>
               <a:t>Fourth level</a:t>
             </a:r>
           </a:p>
           <a:p>
             <a:pPr lvl="4"/>
             <a:r>
-              <a:rPr lang="en-US" smtClean="0"/>
+              <a:rPr lang="en-US"/>
               <a:t>Fifth level</a:t>
             </a:r>
-            <a:endParaRPr lang="en-US"/>
           </a:p>
         </p:txBody>
       </p:sp>
@@ -819,7 +827,7 @@
           <a:p>
             <a:fld id="{5BCAD085-E8A6-8845-BD4E-CB4CCA059FC4}" type="datetimeFigureOut">
               <a:rPr lang="en-US" smtClean="0"/>
-              <a:t>1/27/13</a:t>
+              <a:t>10/29/2026</a:t>
             </a:fld>
             <a:endParaRPr lang="en-US"/>
           </a:p>
@@ -922,10 +930,9 @@
           </a:lstStyle>
           <a:p>
             <a:r>
-              <a:rPr lang="en-US" smtClean="0"/>
+              <a:rPr lang="en-US"/>
               <a:t>Click to edit Master title style</a:t>
             </a:r>
-            <a:endParaRPr lang="en-US"/>
           </a:p>
         </p:txBody>
       </p:sp>
@@ -1042,7 +1049,7 @@
           <a:p>
             <a:pPr lvl="0"/>
             <a:r>
-              <a:rPr lang="en-US" smtClean="0"/>
+              <a:rPr lang="en-US"/>
               <a:t>Click to edit Master text styles</a:t>
             </a:r>
           </a:p>
@@ -1065,7 +1072,7 @@
           <a:p>
             <a:fld id="{5BCAD085-E8A6-8845-BD4E-CB4CCA059FC4}" type="datetimeFigureOut">
               <a:rPr lang="en-US" smtClean="0"/>
-              <a:t>1/27/13</a:t>
+              <a:t>10/29/2026</a:t>
             </a:fld>
             <a:endParaRPr lang="en-US"/>
           </a:p>
@@ -1159,10 +1166,9 @@
           <a:lstStyle/>
           <a:p>
             <a:r>
-              <a:rPr lang="en-US" smtClean="0"/>
+              <a:rPr lang="en-US"/>
               <a:t>Click to edit Master title style</a:t>
             </a:r>
-            <a:endParaRPr lang="en-US"/>
           </a:p>
         </p:txBody>
       </p:sp>
@@ -1216,38 +1222,37 @@
           <a:p>
             <a:pPr lvl="0"/>
             <a:r>
-              <a:rPr lang="en-US" smtClean="0"/>
+              <a:rPr lang="en-US"/>
               <a:t>Click to edit Master text styles</a:t>
             </a:r>
           </a:p>
           <a:p>
             <a:pPr lvl="1"/>
             <a:r>
-              <a:rPr lang="en-US" smtClean="0"/>
+              <a:rPr lang="en-US"/>
               <a:t>Second level</a:t>
             </a:r>
           </a:p>
           <a:p>
             <a:pPr lvl="2"/>
             <a:r>
-              <a:rPr lang="en-US" smtClean="0"/>
+              <a:rPr lang="en-US"/>
               <a:t>Third level</a:t>
             </a:r>
           </a:p>
           <a:p>
             <a:pPr lvl="3"/>
             <a:r>
-              <a:rPr lang="en-US" smtClean="0"/>
+              <a:rPr lang="en-US"/>
               <a:t>Fourth level</a:t>
             </a:r>
           </a:p>
           <a:p>
             <a:pPr lvl="4"/>
             <a:r>
-              <a:rPr lang="en-US" smtClean="0"/>
+              <a:rPr lang="en-US"/>
               <a:t>Fifth level</a:t>
             </a:r>
-            <a:endParaRPr lang="en-US"/>
           </a:p>
         </p:txBody>
       </p:sp>
@@ -1301,38 +1306,37 @@
           <a:p>
             <a:pPr lvl="0"/>
             <a:r>
-              <a:rPr lang="en-US" smtClean="0"/>
+              <a:rPr lang="en-US"/>
               <a:t>Click to edit Master text styles</a:t>
             </a:r>
           </a:p>
           <a:p>
             <a:pPr lvl="1"/>
             <a:r>
-              <a:rPr lang="en-US" smtClean="0"/>
+              <a:rPr lang="en-US"/>
               <a:t>Second level</a:t>
             </a:r>
           </a:p>
           <a:p>
             <a:pPr lvl="2"/>
             <a:r>
-              <a:rPr lang="en-US" smtClean="0"/>
+              <a:rPr lang="en-US"/>
               <a:t>Third level</a:t>
             </a:r>
           </a:p>
           <a:p>
             <a:pPr lvl="3"/>
             <a:r>
-              <a:rPr lang="en-US" smtClean="0"/>
+              <a:rPr lang="en-US"/>
               <a:t>Fourth level</a:t>
             </a:r>
           </a:p>
           <a:p>
             <a:pPr lvl="4"/>
             <a:r>
-              <a:rPr lang="en-US" smtClean="0"/>
+              <a:rPr lang="en-US"/>
               <a:t>Fifth level</a:t>
             </a:r>
-            <a:endParaRPr lang="en-US"/>
           </a:p>
         </p:txBody>
       </p:sp>
@@ -1353,7 +1357,7 @@
           <a:p>
             <a:fld id="{5BCAD085-E8A6-8845-BD4E-CB4CCA059FC4}" type="datetimeFigureOut">
               <a:rPr lang="en-US" smtClean="0"/>
-              <a:t>1/27/13</a:t>
+              <a:t>10/29/2026</a:t>
             </a:fld>
             <a:endParaRPr lang="en-US"/>
           </a:p>
@@ -1451,10 +1455,9 @@
           </a:lstStyle>
           <a:p>
             <a:r>
-              <a:rPr lang="en-US" smtClean="0"/>
+              <a:rPr lang="en-US"/>
               <a:t>Click to edit Master title style</a:t>
             </a:r>
-            <a:endParaRPr lang="en-US"/>
           </a:p>
         </p:txBody>
       </p:sp>
@@ -1517,7 +1520,7 @@
           <a:p>
             <a:pPr lvl="0"/>
             <a:r>
-              <a:rPr lang="en-US" smtClean="0"/>
+              <a:rPr lang="en-US"/>
               <a:t>Click to edit Master text styles</a:t>
             </a:r>
           </a:p>
@@ -1573,38 +1576,37 @@
           <a:p>
             <a:pPr lvl="0"/>
             <a:r>
-              <a:rPr lang="en-US" smtClean="0"/>
+              <a:rPr lang="en-US"/>
               <a:t>Click to edit Master text styles</a:t>
             </a:r>
           </a:p>
           <a:p>
             <a:pPr lvl="1"/>
             <a:r>
-              <a:rPr lang="en-US" smtClean="0"/>
+              <a:rPr lang="en-US"/>
               <a:t>Second level</a:t>
             </a:r>
           </a:p>
           <a:p>
             <a:pPr lvl="2"/>
             <a:r>
-              <a:rPr lang="en-US" smtClean="0"/>
+              <a:rPr lang="en-US"/>
               <a:t>Third level</a:t>
             </a:r>
           </a:p>
           <a:p>
             <a:pPr lvl="3"/>
             <a:r>
-              <a:rPr lang="en-US" smtClean="0"/>
+              <a:rPr lang="en-US"/>
               <a:t>Fourth level</a:t>
             </a:r>
           </a:p>
           <a:p>
             <a:pPr lvl="4"/>
             <a:r>
-              <a:rPr lang="en-US" smtClean="0"/>
+              <a:rPr lang="en-US"/>
               <a:t>Fifth level</a:t>
             </a:r>
-            <a:endParaRPr lang="en-US"/>
           </a:p>
         </p:txBody>
       </p:sp>
@@ -1667,7 +1669,7 @@
           <a:p>
             <a:pPr lvl="0"/>
             <a:r>
-              <a:rPr lang="en-US" smtClean="0"/>
+              <a:rPr lang="en-US"/>
               <a:t>Click to edit Master text styles</a:t>
             </a:r>
           </a:p>
@@ -1723,38 +1725,37 @@
           <a:p>
             <a:pPr lvl="0"/>
             <a:r>
-              <a:rPr lang="en-US" smtClean="0"/>
+              <a:rPr lang="en-US"/>
               <a:t>Click to edit Master text styles</a:t>
             </a:r>
           </a:p>
           <a:p>
             <a:pPr lvl="1"/>
             <a:r>
-              <a:rPr lang="en-US" smtClean="0"/>
+              <a:rPr lang="en-US"/>
               <a:t>Second level</a:t>
             </a:r>
           </a:p>
           <a:p>
             <a:pPr lvl="2"/>
             <a:r>
-              <a:rPr lang="en-US" smtClean="0"/>
+              <a:rPr lang="en-US"/>
               <a:t>Third level</a:t>
             </a:r>
           </a:p>
           <a:p>
             <a:pPr lvl="3"/>
             <a:r>
-              <a:rPr lang="en-US" smtClean="0"/>
+              <a:rPr lang="en-US"/>
               <a:t>Fourth level</a:t>
             </a:r>
           </a:p>
           <a:p>
             <a:pPr lvl="4"/>
             <a:r>
-              <a:rPr lang="en-US" smtClean="0"/>
+              <a:rPr lang="en-US"/>
               <a:t>Fifth level</a:t>
             </a:r>
-            <a:endParaRPr lang="en-US"/>
           </a:p>
         </p:txBody>
       </p:sp>
@@ -1775,7 +1776,7 @@
           <a:p>
             <a:fld id="{5BCAD085-E8A6-8845-BD4E-CB4CCA059FC4}" type="datetimeFigureOut">
               <a:rPr lang="en-US" smtClean="0"/>
-              <a:t>1/27/13</a:t>
+              <a:t>10/29/2026</a:t>
             </a:fld>
             <a:endParaRPr lang="en-US"/>
           </a:p>
@@ -1869,10 +1870,9 @@
           <a:lstStyle/>
           <a:p>
             <a:r>
-              <a:rPr lang="en-US" smtClean="0"/>
+              <a:rPr lang="en-US"/>
               <a:t>Click to edit Master title style</a:t>
             </a:r>
-            <a:endParaRPr lang="en-US"/>
           </a:p>
         </p:txBody>
       </p:sp>
@@ -1893,7 +1893,7 @@
           <a:p>
             <a:fld id="{5BCAD085-E8A6-8845-BD4E-CB4CCA059FC4}" type="datetimeFigureOut">
               <a:rPr lang="en-US" smtClean="0"/>
-              <a:t>1/27/13</a:t>
+              <a:t>10/29/2026</a:t>
             </a:fld>
             <a:endParaRPr lang="en-US"/>
           </a:p>
@@ -1988,7 +1988,7 @@
           <a:p>
             <a:fld id="{5BCAD085-E8A6-8845-BD4E-CB4CCA059FC4}" type="datetimeFigureOut">
               <a:rPr lang="en-US" smtClean="0"/>
-              <a:t>1/27/13</a:t>
+              <a:t>10/29/2026</a:t>
             </a:fld>
             <a:endParaRPr lang="en-US"/>
           </a:p>
@@ -2091,10 +2091,9 @@
           </a:lstStyle>
           <a:p>
             <a:r>
-              <a:rPr lang="en-US" smtClean="0"/>
+              <a:rPr lang="en-US"/>
               <a:t>Click to edit Master title style</a:t>
             </a:r>
-            <a:endParaRPr lang="en-US"/>
           </a:p>
         </p:txBody>
       </p:sp>
@@ -2148,38 +2147,37 @@
           <a:p>
             <a:pPr lvl="0"/>
             <a:r>
-              <a:rPr lang="en-US" smtClean="0"/>
+              <a:rPr lang="en-US"/>
               <a:t>Click to edit Master text styles</a:t>
             </a:r>
           </a:p>
           <a:p>
             <a:pPr lvl="1"/>
             <a:r>
-              <a:rPr lang="en-US" smtClean="0"/>
+              <a:rPr lang="en-US"/>
               <a:t>Second level</a:t>
             </a:r>
           </a:p>
           <a:p>
             <a:pPr lvl="2"/>
             <a:r>
-              <a:rPr lang="en-US" smtClean="0"/>
+              <a:rPr lang="en-US"/>
               <a:t>Third level</a:t>
             </a:r>
           </a:p>
           <a:p>
             <a:pPr lvl="3"/>
             <a:r>
-              <a:rPr lang="en-US" smtClean="0"/>
+              <a:rPr lang="en-US"/>
               <a:t>Fourth level</a:t>
             </a:r>
           </a:p>
           <a:p>
             <a:pPr lvl="4"/>
             <a:r>
-              <a:rPr lang="en-US" smtClean="0"/>
+              <a:rPr lang="en-US"/>
               <a:t>Fifth level</a:t>
             </a:r>
-            <a:endParaRPr lang="en-US"/>
           </a:p>
         </p:txBody>
       </p:sp>
@@ -2242,7 +2240,7 @@
           <a:p>
             <a:pPr lvl="0"/>
             <a:r>
-              <a:rPr lang="en-US" smtClean="0"/>
+              <a:rPr lang="en-US"/>
               <a:t>Click to edit Master text styles</a:t>
             </a:r>
           </a:p>
@@ -2265,7 +2263,7 @@
           <a:p>
             <a:fld id="{5BCAD085-E8A6-8845-BD4E-CB4CCA059FC4}" type="datetimeFigureOut">
               <a:rPr lang="en-US" smtClean="0"/>
-              <a:t>1/27/13</a:t>
+              <a:t>10/29/2026</a:t>
             </a:fld>
             <a:endParaRPr lang="en-US"/>
           </a:p>
@@ -2368,10 +2366,9 @@
           </a:lstStyle>
           <a:p>
             <a:r>
-              <a:rPr lang="en-US" smtClean="0"/>
+              <a:rPr lang="en-US"/>
               <a:t>Click to edit Master title style</a:t>
             </a:r>
-            <a:endParaRPr lang="en-US"/>
           </a:p>
         </p:txBody>
       </p:sp>
@@ -2495,7 +2492,7 @@
           <a:p>
             <a:pPr lvl="0"/>
             <a:r>
-              <a:rPr lang="en-US" smtClean="0"/>
+              <a:rPr lang="en-US"/>
               <a:t>Click to edit Master text styles</a:t>
             </a:r>
           </a:p>
@@ -2518,7 +2515,7 @@
           <a:p>
             <a:fld id="{5BCAD085-E8A6-8845-BD4E-CB4CCA059FC4}" type="datetimeFigureOut">
               <a:rPr lang="en-US" smtClean="0"/>
-              <a:t>1/27/13</a:t>
+              <a:t>10/29/2026</a:t>
             </a:fld>
             <a:endParaRPr lang="en-US"/>
           </a:p>
@@ -2627,10 +2624,9 @@
           <a:lstStyle/>
           <a:p>
             <a:r>
-              <a:rPr lang="en-US" smtClean="0"/>
+              <a:rPr lang="en-US"/>
               <a:t>Click to edit Master title style</a:t>
             </a:r>
-            <a:endParaRPr lang="en-US"/>
           </a:p>
         </p:txBody>
       </p:sp>
@@ -2661,38 +2657,37 @@
           <a:p>
             <a:pPr lvl="0"/>
             <a:r>
-              <a:rPr lang="en-US" smtClean="0"/>
+              <a:rPr lang="en-US"/>
               <a:t>Click to edit Master text styles</a:t>
             </a:r>
           </a:p>
           <a:p>
             <a:pPr lvl="1"/>
             <a:r>
-              <a:rPr lang="en-US" smtClean="0"/>
+              <a:rPr lang="en-US"/>
               <a:t>Second level</a:t>
             </a:r>
           </a:p>
           <a:p>
             <a:pPr lvl="2"/>
             <a:r>
-              <a:rPr lang="en-US" smtClean="0"/>
+              <a:rPr lang="en-US"/>
               <a:t>Third level</a:t>
             </a:r>
           </a:p>
           <a:p>
             <a:pPr lvl="3"/>
             <a:r>
-              <a:rPr lang="en-US" smtClean="0"/>
+              <a:rPr lang="en-US"/>
               <a:t>Fourth level</a:t>
             </a:r>
           </a:p>
           <a:p>
             <a:pPr lvl="4"/>
             <a:r>
-              <a:rPr lang="en-US" smtClean="0"/>
+              <a:rPr lang="en-US"/>
               <a:t>Fifth level</a:t>
             </a:r>
-            <a:endParaRPr lang="en-US"/>
           </a:p>
         </p:txBody>
       </p:sp>
@@ -2731,7 +2726,7 @@
           <a:p>
             <a:fld id="{5BCAD085-E8A6-8845-BD4E-CB4CCA059FC4}" type="datetimeFigureOut">
               <a:rPr lang="en-US" smtClean="0"/>
-              <a:t>1/27/13</a:t>
+              <a:t>10/29/2026</a:t>
             </a:fld>
             <a:endParaRPr lang="en-US"/>
           </a:p>
@@ -3090,7 +3085,7 @@
 </file>
 
 <file path=ppt/slides/slide1.xml><?xml version="1.0" encoding="utf-8"?>
-<p:sld xmlns:a="http://schemas.openxmlformats.org/drawingml/2006/main" xmlns:p="http://schemas.openxmlformats.org/presentationml/2006/main" xmlns:r="http://schemas.openxmlformats.org/officeDocument/2006/relationships">
+<p:sld xmlns:a="http://schemas.openxmlformats.org/drawingml/2006/main" xmlns:r="http://schemas.openxmlformats.org/officeDocument/2006/relationships" xmlns:p="http://schemas.openxmlformats.org/presentationml/2006/main">
   <p:cSld>
     <p:spTree>
       <p:nvGrpSpPr>
@@ -3098,7 +3093,14 @@
         <p:cNvGrpSpPr/>
         <p:nvPr/>
       </p:nvGrpSpPr>
-      <p:grpSpPr/>
+      <p:grpSpPr>
+        <a:xfrm>
+          <a:off x="0" y="0"/>
+          <a:ext cx="0" cy="0"/>
+          <a:chOff x="0" y="0"/>
+          <a:chExt cx="0" cy="0"/>
+        </a:xfrm>
+      </p:grpSpPr>
       <p:sp>
         <p:nvSpPr>
           <p:cNvPr id="2" name="Rectangle 1"/>
@@ -3139,6 +3141,7 @@
           <a:lstStyle/>
           <a:p>
             <a:pPr algn="ctr"/>
+            <a:endParaRPr/>
           </a:p>
         </p:txBody>
       </p:sp>
@@ -3184,6 +3187,7 @@
           <a:lstStyle/>
           <a:p>
             <a:pPr algn="ctr"/>
+            <a:endParaRPr/>
           </a:p>
         </p:txBody>
       </p:sp>
@@ -3364,7 +3368,7 @@
 </file>
 
 <file path=ppt/slides/slide10.xml><?xml version="1.0" encoding="utf-8"?>
-<p:sld xmlns:a="http://schemas.openxmlformats.org/drawingml/2006/main" xmlns:p="http://schemas.openxmlformats.org/presentationml/2006/main" xmlns:r="http://schemas.openxmlformats.org/officeDocument/2006/relationships">
+<p:sld xmlns:a="http://schemas.openxmlformats.org/drawingml/2006/main" xmlns:r="http://schemas.openxmlformats.org/officeDocument/2006/relationships" xmlns:p="http://schemas.openxmlformats.org/presentationml/2006/main">
   <p:cSld>
     <p:spTree>
       <p:nvGrpSpPr>
@@ -3372,7 +3376,14 @@
         <p:cNvGrpSpPr/>
         <p:nvPr/>
       </p:nvGrpSpPr>
-      <p:grpSpPr/>
+      <p:grpSpPr>
+        <a:xfrm>
+          <a:off x="0" y="0"/>
+          <a:ext cx="0" cy="0"/>
+          <a:chOff x="0" y="0"/>
+          <a:chExt cx="0" cy="0"/>
+        </a:xfrm>
+      </p:grpSpPr>
       <p:sp>
         <p:nvSpPr>
           <p:cNvPr id="2" name="TextBox 1"/>
@@ -3487,6 +3498,7 @@
           <a:lstStyle/>
           <a:p>
             <a:pPr algn="ctr"/>
+            <a:endParaRPr/>
           </a:p>
         </p:txBody>
       </p:sp>
@@ -3532,6 +3544,7 @@
           <a:lstStyle/>
           <a:p>
             <a:pPr algn="ctr"/>
+            <a:endParaRPr/>
           </a:p>
         </p:txBody>
       </p:sp>
@@ -3574,7 +3587,7 @@
               <a:spcAft>
                 <a:spcPts val="200"/>
               </a:spcAft>
-              <a:defRPr b="1" sz="950">
+              <a:defRPr sz="950" b="1">
                 <a:solidFill>
                   <a:srgbClr val="DC2626"/>
                 </a:solidFill>
@@ -3594,7 +3607,7 @@
           </a:p>
           <a:p>
             <a:pPr>
-              <a:defRPr b="1" sz="950">
+              <a:defRPr sz="950" b="1">
                 <a:solidFill>
                   <a:srgbClr val="16A34A"/>
                 </a:solidFill>
@@ -3656,6 +3669,7 @@
           <a:lstStyle/>
           <a:p>
             <a:pPr algn="ctr"/>
+            <a:endParaRPr/>
           </a:p>
         </p:txBody>
       </p:sp>
@@ -3698,7 +3712,7 @@
               <a:spcAft>
                 <a:spcPts val="200"/>
               </a:spcAft>
-              <a:defRPr b="1" sz="950">
+              <a:defRPr sz="950" b="1">
                 <a:solidFill>
                   <a:srgbClr val="DC2626"/>
                 </a:solidFill>
@@ -3718,7 +3732,7 @@
           </a:p>
           <a:p>
             <a:pPr>
-              <a:defRPr b="1" sz="950">
+              <a:defRPr sz="950" b="1">
                 <a:solidFill>
                   <a:srgbClr val="16A34A"/>
                 </a:solidFill>
@@ -3780,6 +3794,7 @@
           <a:lstStyle/>
           <a:p>
             <a:pPr algn="ctr"/>
+            <a:endParaRPr/>
           </a:p>
         </p:txBody>
       </p:sp>
@@ -3822,7 +3837,7 @@
               <a:spcAft>
                 <a:spcPts val="200"/>
               </a:spcAft>
-              <a:defRPr b="1" sz="950">
+              <a:defRPr sz="950" b="1">
                 <a:solidFill>
                   <a:srgbClr val="DC2626"/>
                 </a:solidFill>
@@ -3842,7 +3857,7 @@
           </a:p>
           <a:p>
             <a:pPr>
-              <a:defRPr b="1" sz="950">
+              <a:defRPr sz="950" b="1">
                 <a:solidFill>
                   <a:srgbClr val="16A34A"/>
                 </a:solidFill>
@@ -3904,6 +3919,7 @@
           <a:lstStyle/>
           <a:p>
             <a:pPr algn="ctr"/>
+            <a:endParaRPr/>
           </a:p>
         </p:txBody>
       </p:sp>
@@ -3946,7 +3962,7 @@
               <a:spcAft>
                 <a:spcPts val="200"/>
               </a:spcAft>
-              <a:defRPr b="1" sz="950">
+              <a:defRPr sz="950" b="1">
                 <a:solidFill>
                   <a:srgbClr val="DC2626"/>
                 </a:solidFill>
@@ -3966,7 +3982,7 @@
           </a:p>
           <a:p>
             <a:pPr>
-              <a:defRPr b="1" sz="950">
+              <a:defRPr sz="950" b="1">
                 <a:solidFill>
                   <a:srgbClr val="16A34A"/>
                 </a:solidFill>
@@ -3995,7 +4011,7 @@
 </file>
 
 <file path=ppt/slides/slide11.xml><?xml version="1.0" encoding="utf-8"?>
-<p:sld xmlns:a="http://schemas.openxmlformats.org/drawingml/2006/main" xmlns:p="http://schemas.openxmlformats.org/presentationml/2006/main" xmlns:r="http://schemas.openxmlformats.org/officeDocument/2006/relationships">
+<p:sld xmlns:a="http://schemas.openxmlformats.org/drawingml/2006/main" xmlns:r="http://schemas.openxmlformats.org/officeDocument/2006/relationships" xmlns:p="http://schemas.openxmlformats.org/presentationml/2006/main">
   <p:cSld>
     <p:spTree>
       <p:nvGrpSpPr>
@@ -4003,7 +4019,14 @@
         <p:cNvGrpSpPr/>
         <p:nvPr/>
       </p:nvGrpSpPr>
-      <p:grpSpPr/>
+      <p:grpSpPr>
+        <a:xfrm>
+          <a:off x="0" y="0"/>
+          <a:ext cx="0" cy="0"/>
+          <a:chOff x="0" y="0"/>
+          <a:chExt cx="0" cy="0"/>
+        </a:xfrm>
+      </p:grpSpPr>
       <p:sp>
         <p:nvSpPr>
           <p:cNvPr id="2" name="TextBox 1"/>
@@ -4118,6 +4141,7 @@
           <a:lstStyle/>
           <a:p>
             <a:pPr algn="ctr"/>
+            <a:endParaRPr/>
           </a:p>
         </p:txBody>
       </p:sp>
@@ -4163,6 +4187,7 @@
           <a:lstStyle/>
           <a:p>
             <a:pPr algn="ctr"/>
+            <a:endParaRPr/>
           </a:p>
         </p:txBody>
       </p:sp>
@@ -4292,6 +4317,7 @@
           <a:lstStyle/>
           <a:p>
             <a:pPr algn="ctr"/>
+            <a:endParaRPr/>
           </a:p>
         </p:txBody>
       </p:sp>
@@ -4421,6 +4447,7 @@
           <a:lstStyle/>
           <a:p>
             <a:pPr algn="ctr"/>
+            <a:endParaRPr/>
           </a:p>
         </p:txBody>
       </p:sp>
@@ -4550,6 +4577,7 @@
           <a:lstStyle/>
           <a:p>
             <a:pPr algn="ctr"/>
+            <a:endParaRPr/>
           </a:p>
         </p:txBody>
       </p:sp>
@@ -4646,7 +4674,7 @@
 </file>
 
 <file path=ppt/slides/slide12.xml><?xml version="1.0" encoding="utf-8"?>
-<p:sld xmlns:a="http://schemas.openxmlformats.org/drawingml/2006/main" xmlns:p="http://schemas.openxmlformats.org/presentationml/2006/main" xmlns:r="http://schemas.openxmlformats.org/officeDocument/2006/relationships">
+<p:sld xmlns:a="http://schemas.openxmlformats.org/drawingml/2006/main" xmlns:r="http://schemas.openxmlformats.org/officeDocument/2006/relationships" xmlns:p="http://schemas.openxmlformats.org/presentationml/2006/main">
   <p:cSld>
     <p:spTree>
       <p:nvGrpSpPr>
@@ -4654,7 +4682,14 @@
         <p:cNvGrpSpPr/>
         <p:nvPr/>
       </p:nvGrpSpPr>
-      <p:grpSpPr/>
+      <p:grpSpPr>
+        <a:xfrm>
+          <a:off x="0" y="0"/>
+          <a:ext cx="0" cy="0"/>
+          <a:chOff x="0" y="0"/>
+          <a:chExt cx="0" cy="0"/>
+        </a:xfrm>
+      </p:grpSpPr>
       <p:sp>
         <p:nvSpPr>
           <p:cNvPr id="2" name="Rectangle 1"/>
@@ -4695,6 +4730,7 @@
           <a:lstStyle/>
           <a:p>
             <a:pPr algn="ctr"/>
+            <a:endParaRPr/>
           </a:p>
         </p:txBody>
       </p:sp>
@@ -4740,6 +4776,7 @@
           <a:lstStyle/>
           <a:p>
             <a:pPr algn="ctr"/>
+            <a:endParaRPr/>
           </a:p>
         </p:txBody>
       </p:sp>
@@ -4939,14 +4976,6 @@
           </a:p>
           <a:p>
             <a:br/>
-            <a:pPr algn="ctr">
-              <a:defRPr sz="1600" b="1">
-                <a:solidFill>
-                  <a:srgbClr val="0284C7"/>
-                </a:solidFill>
-                <a:latin typeface="Segoe UI"/>
-              </a:defRPr>
-            </a:pPr>
             <a:r>
               <a:t>Thank You!  —  Questions &amp; Discussion</a:t>
             </a:r>
@@ -4962,7 +4991,7 @@
 </file>
 
 <file path=ppt/slides/slide2.xml><?xml version="1.0" encoding="utf-8"?>
-<p:sld xmlns:a="http://schemas.openxmlformats.org/drawingml/2006/main" xmlns:p="http://schemas.openxmlformats.org/presentationml/2006/main" xmlns:r="http://schemas.openxmlformats.org/officeDocument/2006/relationships">
+<p:sld xmlns:a="http://schemas.openxmlformats.org/drawingml/2006/main" xmlns:r="http://schemas.openxmlformats.org/officeDocument/2006/relationships" xmlns:p="http://schemas.openxmlformats.org/presentationml/2006/main">
   <p:cSld>
     <p:spTree>
       <p:nvGrpSpPr>
@@ -4970,7 +4999,14 @@
         <p:cNvGrpSpPr/>
         <p:nvPr/>
       </p:nvGrpSpPr>
-      <p:grpSpPr/>
+      <p:grpSpPr>
+        <a:xfrm>
+          <a:off x="0" y="0"/>
+          <a:ext cx="0" cy="0"/>
+          <a:chOff x="0" y="0"/>
+          <a:chExt cx="0" cy="0"/>
+        </a:xfrm>
+      </p:grpSpPr>
       <p:sp>
         <p:nvSpPr>
           <p:cNvPr id="2" name="TextBox 1"/>
@@ -5085,6 +5121,7 @@
           <a:lstStyle/>
           <a:p>
             <a:pPr algn="ctr"/>
+            <a:endParaRPr/>
           </a:p>
         </p:txBody>
       </p:sp>
@@ -5130,6 +5167,7 @@
           <a:lstStyle/>
           <a:p>
             <a:pPr algn="ctr"/>
+            <a:endParaRPr/>
           </a:p>
         </p:txBody>
       </p:sp>
@@ -5275,6 +5313,7 @@
           <a:lstStyle/>
           <a:p>
             <a:pPr algn="ctr"/>
+            <a:endParaRPr/>
           </a:p>
         </p:txBody>
       </p:sp>
@@ -5420,6 +5459,7 @@
           <a:lstStyle/>
           <a:p>
             <a:pPr algn="ctr"/>
+            <a:endParaRPr/>
           </a:p>
         </p:txBody>
       </p:sp>
@@ -5565,6 +5605,7 @@
           <a:lstStyle/>
           <a:p>
             <a:pPr algn="ctr"/>
+            <a:endParaRPr/>
           </a:p>
         </p:txBody>
       </p:sp>
@@ -5677,7 +5718,7 @@
 </file>
 
 <file path=ppt/slides/slide3.xml><?xml version="1.0" encoding="utf-8"?>
-<p:sld xmlns:a="http://schemas.openxmlformats.org/drawingml/2006/main" xmlns:p="http://schemas.openxmlformats.org/presentationml/2006/main" xmlns:r="http://schemas.openxmlformats.org/officeDocument/2006/relationships">
+<p:sld xmlns:a="http://schemas.openxmlformats.org/drawingml/2006/main" xmlns:r="http://schemas.openxmlformats.org/officeDocument/2006/relationships" xmlns:p="http://schemas.openxmlformats.org/presentationml/2006/main">
   <p:cSld>
     <p:spTree>
       <p:nvGrpSpPr>
@@ -5685,7 +5726,14 @@
         <p:cNvGrpSpPr/>
         <p:nvPr/>
       </p:nvGrpSpPr>
-      <p:grpSpPr/>
+      <p:grpSpPr>
+        <a:xfrm>
+          <a:off x="0" y="0"/>
+          <a:ext cx="0" cy="0"/>
+          <a:chOff x="0" y="0"/>
+          <a:chExt cx="0" cy="0"/>
+        </a:xfrm>
+      </p:grpSpPr>
       <p:sp>
         <p:nvSpPr>
           <p:cNvPr id="2" name="TextBox 1"/>
@@ -5800,6 +5848,7 @@
           <a:lstStyle/>
           <a:p>
             <a:pPr algn="ctr"/>
+            <a:endParaRPr/>
           </a:p>
         </p:txBody>
       </p:sp>
@@ -5845,6 +5894,7 @@
           <a:lstStyle/>
           <a:p>
             <a:pPr algn="ctr"/>
+            <a:endParaRPr/>
           </a:p>
         </p:txBody>
       </p:sp>
@@ -6094,6 +6144,7 @@
           <a:lstStyle/>
           <a:p>
             <a:pPr algn="ctr"/>
+            <a:endParaRPr/>
           </a:p>
         </p:txBody>
       </p:sp>
@@ -6130,7 +6181,7 @@
 </file>
 
 <file path=ppt/slides/slide4.xml><?xml version="1.0" encoding="utf-8"?>
-<p:sld xmlns:a="http://schemas.openxmlformats.org/drawingml/2006/main" xmlns:p="http://schemas.openxmlformats.org/presentationml/2006/main" xmlns:r="http://schemas.openxmlformats.org/officeDocument/2006/relationships">
+<p:sld xmlns:a="http://schemas.openxmlformats.org/drawingml/2006/main" xmlns:r="http://schemas.openxmlformats.org/officeDocument/2006/relationships" xmlns:p="http://schemas.openxmlformats.org/presentationml/2006/main">
   <p:cSld>
     <p:spTree>
       <p:nvGrpSpPr>
@@ -6138,7 +6189,14 @@
         <p:cNvGrpSpPr/>
         <p:nvPr/>
       </p:nvGrpSpPr>
-      <p:grpSpPr/>
+      <p:grpSpPr>
+        <a:xfrm>
+          <a:off x="0" y="0"/>
+          <a:ext cx="0" cy="0"/>
+          <a:chOff x="0" y="0"/>
+          <a:chExt cx="0" cy="0"/>
+        </a:xfrm>
+      </p:grpSpPr>
       <p:sp>
         <p:nvSpPr>
           <p:cNvPr id="2" name="TextBox 1"/>
@@ -6253,6 +6311,7 @@
           <a:lstStyle/>
           <a:p>
             <a:pPr algn="ctr"/>
+            <a:endParaRPr/>
           </a:p>
         </p:txBody>
       </p:sp>
@@ -6298,6 +6357,7 @@
           <a:lstStyle/>
           <a:p>
             <a:pPr algn="ctr"/>
+            <a:endParaRPr/>
           </a:p>
         </p:txBody>
       </p:sp>
@@ -6499,6 +6559,7 @@
           <a:lstStyle/>
           <a:p>
             <a:pPr algn="ctr"/>
+            <a:endParaRPr/>
           </a:p>
         </p:txBody>
       </p:sp>
@@ -6535,7 +6596,7 @@
 </file>
 
 <file path=ppt/slides/slide5.xml><?xml version="1.0" encoding="utf-8"?>
-<p:sld xmlns:a="http://schemas.openxmlformats.org/drawingml/2006/main" xmlns:p="http://schemas.openxmlformats.org/presentationml/2006/main" xmlns:r="http://schemas.openxmlformats.org/officeDocument/2006/relationships">
+<p:sld xmlns:a="http://schemas.openxmlformats.org/drawingml/2006/main" xmlns:r="http://schemas.openxmlformats.org/officeDocument/2006/relationships" xmlns:p="http://schemas.openxmlformats.org/presentationml/2006/main">
   <p:cSld>
     <p:spTree>
       <p:nvGrpSpPr>
@@ -6543,7 +6604,14 @@
         <p:cNvGrpSpPr/>
         <p:nvPr/>
       </p:nvGrpSpPr>
-      <p:grpSpPr/>
+      <p:grpSpPr>
+        <a:xfrm>
+          <a:off x="0" y="0"/>
+          <a:ext cx="0" cy="0"/>
+          <a:chOff x="0" y="0"/>
+          <a:chExt cx="0" cy="0"/>
+        </a:xfrm>
+      </p:grpSpPr>
       <p:sp>
         <p:nvSpPr>
           <p:cNvPr id="2" name="TextBox 1"/>
@@ -6611,7 +6679,16 @@
               </a:defRPr>
             </a:pPr>
             <a:r>
-              <a:t>Production Dockerfile &amp; Security Hardening</a:t>
+              <a:rPr dirty="0"/>
+              <a:t>Production </a:t>
+            </a:r>
+            <a:r>
+              <a:rPr dirty="0" err="1"/>
+              <a:t>Dockerfile</a:t>
+            </a:r>
+            <a:r>
+              <a:rPr dirty="0"/>
+              <a:t> &amp; Security Hardening</a:t>
             </a:r>
           </a:p>
         </p:txBody>
@@ -6658,6 +6735,7 @@
           <a:lstStyle/>
           <a:p>
             <a:pPr algn="ctr"/>
+            <a:endParaRPr/>
           </a:p>
         </p:txBody>
       </p:sp>
@@ -6703,6 +6781,7 @@
           <a:lstStyle/>
           <a:p>
             <a:pPr algn="ctr"/>
+            <a:endParaRPr/>
           </a:p>
         </p:txBody>
       </p:sp>
@@ -6737,6 +6816,7 @@
               </a:defRPr>
             </a:pPr>
             <a:r>
+              <a:rPr dirty="0"/>
               <a:t>Containerization Standards</a:t>
             </a:r>
           </a:p>
@@ -6753,10 +6833,11 @@
               </a:defRPr>
             </a:pPr>
             <a:r>
+              <a:rPr dirty="0"/>
               <a:t>• Multi-Stage Build Pattern: </a:t>
             </a:r>
             <a:r>
-              <a:rPr b="0">
+              <a:rPr b="0" dirty="0">
                 <a:solidFill>
                   <a:srgbClr val="64748B"/>
                 </a:solidFill>
@@ -6777,15 +6858,64 @@
               </a:defRPr>
             </a:pPr>
             <a:r>
+              <a:rPr dirty="0"/>
               <a:t>• Non-Root Security Context: </a:t>
             </a:r>
             <a:r>
-              <a:rPr b="0">
+              <a:rPr b="0" dirty="0">
                 <a:solidFill>
                   <a:srgbClr val="64748B"/>
                 </a:solidFill>
               </a:rPr>
-              <a:t>Runs as dedicated appuser (UID 1000) with chown -R appuser:appuser /app to mitigate container breakout risks.</a:t>
+              <a:t>Runs as dedicated </a:t>
+            </a:r>
+            <a:r>
+              <a:rPr b="0" dirty="0" err="1">
+                <a:solidFill>
+                  <a:srgbClr val="64748B"/>
+                </a:solidFill>
+              </a:rPr>
+              <a:t>appuser</a:t>
+            </a:r>
+            <a:r>
+              <a:rPr b="0" dirty="0">
+                <a:solidFill>
+                  <a:srgbClr val="64748B"/>
+                </a:solidFill>
+              </a:rPr>
+              <a:t> (UID 1000) with </a:t>
+            </a:r>
+            <a:r>
+              <a:rPr b="0" dirty="0" err="1">
+                <a:solidFill>
+                  <a:srgbClr val="64748B"/>
+                </a:solidFill>
+              </a:rPr>
+              <a:t>chown</a:t>
+            </a:r>
+            <a:r>
+              <a:rPr b="0" dirty="0">
+                <a:solidFill>
+                  <a:srgbClr val="64748B"/>
+                </a:solidFill>
+              </a:rPr>
+              <a:t> -R </a:t>
+            </a:r>
+            <a:r>
+              <a:rPr b="0" dirty="0" err="1">
+                <a:solidFill>
+                  <a:srgbClr val="64748B"/>
+                </a:solidFill>
+              </a:rPr>
+              <a:t>appuser:appuser</a:t>
+            </a:r>
+            <a:r>
+              <a:rPr b="0" dirty="0">
+                <a:solidFill>
+                  <a:srgbClr val="64748B"/>
+                </a:solidFill>
+              </a:rPr>
+              <a:t> /app to mitigate container breakout risks.</a:t>
             </a:r>
           </a:p>
           <a:p>
@@ -6801,10 +6931,19 @@
               </a:defRPr>
             </a:pPr>
             <a:r>
-              <a:t>• Container Healthcheck: </a:t>
-            </a:r>
-            <a:r>
-              <a:rPr b="0">
+              <a:rPr dirty="0"/>
+              <a:t>• Container </a:t>
+            </a:r>
+            <a:r>
+              <a:rPr dirty="0" err="1"/>
+              <a:t>Healthcheck</a:t>
+            </a:r>
+            <a:r>
+              <a:rPr dirty="0"/>
+              <a:t>: </a:t>
+            </a:r>
+            <a:r>
+              <a:rPr b="0" dirty="0">
                 <a:solidFill>
                   <a:srgbClr val="64748B"/>
                 </a:solidFill>
@@ -6825,15 +6964,32 @@
               </a:defRPr>
             </a:pPr>
             <a:r>
+              <a:rPr dirty="0"/>
               <a:t>• Local Multi-Service Compose: </a:t>
             </a:r>
             <a:r>
-              <a:rPr b="0">
+              <a:rPr b="0" dirty="0">
                 <a:solidFill>
                   <a:srgbClr val="64748B"/>
                 </a:solidFill>
               </a:rPr>
-              <a:t>docker-compose.yml defines local developer environment with web and nginx services sharing a bridge network.</a:t>
+              <a:t>docker-</a:t>
+            </a:r>
+            <a:r>
+              <a:rPr b="0" dirty="0" err="1">
+                <a:solidFill>
+                  <a:srgbClr val="64748B"/>
+                </a:solidFill>
+              </a:rPr>
+              <a:t>compose.yml</a:t>
+            </a:r>
+            <a:r>
+              <a:rPr b="0" dirty="0">
+                <a:solidFill>
+                  <a:srgbClr val="64748B"/>
+                </a:solidFill>
+              </a:rPr>
+              <a:t> defines local developer environment with web and nginx services sharing a bridge network.</a:t>
             </a:r>
           </a:p>
           <a:p>
@@ -6849,15 +7005,32 @@
               </a:defRPr>
             </a:pPr>
             <a:r>
+              <a:rPr dirty="0"/>
               <a:t>• Minimal Image Footprint: </a:t>
             </a:r>
             <a:r>
-              <a:rPr b="0">
+              <a:rPr b="0" dirty="0">
                 <a:solidFill>
                   <a:srgbClr val="64748B"/>
                 </a:solidFill>
               </a:rPr>
-              <a:t>Utilizes .dockerignore to strip caches, git history, and secrets, reducing attack surface and pull latency.</a:t>
+              <a:t>Utilizes .</a:t>
+            </a:r>
+            <a:r>
+              <a:rPr b="0" dirty="0" err="1">
+                <a:solidFill>
+                  <a:srgbClr val="64748B"/>
+                </a:solidFill>
+              </a:rPr>
+              <a:t>dockerignore</a:t>
+            </a:r>
+            <a:r>
+              <a:rPr b="0" dirty="0">
+                <a:solidFill>
+                  <a:srgbClr val="64748B"/>
+                </a:solidFill>
+              </a:rPr>
+              <a:t> to strip caches, git history, and secrets, reducing attack surface and pull latency.</a:t>
             </a:r>
           </a:p>
         </p:txBody>
@@ -6904,6 +7077,7 @@
           <a:lstStyle/>
           <a:p>
             <a:pPr algn="ctr"/>
+            <a:endParaRPr/>
           </a:p>
         </p:txBody>
       </p:sp>
@@ -6940,7 +7114,7 @@
 </file>
 
 <file path=ppt/slides/slide6.xml><?xml version="1.0" encoding="utf-8"?>
-<p:sld xmlns:a="http://schemas.openxmlformats.org/drawingml/2006/main" xmlns:p="http://schemas.openxmlformats.org/presentationml/2006/main" xmlns:r="http://schemas.openxmlformats.org/officeDocument/2006/relationships">
+<p:sld xmlns:a="http://schemas.openxmlformats.org/drawingml/2006/main" xmlns:r="http://schemas.openxmlformats.org/officeDocument/2006/relationships" xmlns:p="http://schemas.openxmlformats.org/presentationml/2006/main">
   <p:cSld>
     <p:spTree>
       <p:nvGrpSpPr>
@@ -6948,7 +7122,14 @@
         <p:cNvGrpSpPr/>
         <p:nvPr/>
       </p:nvGrpSpPr>
-      <p:grpSpPr/>
+      <p:grpSpPr>
+        <a:xfrm>
+          <a:off x="0" y="0"/>
+          <a:ext cx="0" cy="0"/>
+          <a:chOff x="0" y="0"/>
+          <a:chExt cx="0" cy="0"/>
+        </a:xfrm>
+      </p:grpSpPr>
       <p:sp>
         <p:nvSpPr>
           <p:cNvPr id="2" name="TextBox 1"/>
@@ -7063,6 +7244,7 @@
           <a:lstStyle/>
           <a:p>
             <a:pPr algn="ctr"/>
+            <a:endParaRPr/>
           </a:p>
         </p:txBody>
       </p:sp>
@@ -7108,6 +7290,7 @@
           <a:lstStyle/>
           <a:p>
             <a:pPr algn="ctr"/>
+            <a:endParaRPr/>
           </a:p>
         </p:txBody>
       </p:sp>
@@ -7309,12 +7492,19 @@
           <a:lstStyle/>
           <a:p>
             <a:pPr algn="ctr"/>
+            <a:endParaRPr/>
           </a:p>
         </p:txBody>
       </p:sp>
       <p:pic>
         <p:nvPicPr>
-          <p:cNvPr id="8" name="Picture 7" descr="jenkins_build_success_live.png"/>
+          <p:cNvPr id="10" name="Picture 9">
+            <a:extLst>
+              <a:ext uri="{FF2B5EF4-FFF2-40B4-BE49-F238E27FC236}">
+                <a16:creationId xmlns:a16="http://schemas.microsoft.com/office/drawing/2014/main" id="{20293E02-B906-278D-D238-340C9A6A7DD4}"/>
+              </a:ext>
+            </a:extLst>
+          </p:cNvPr>
           <p:cNvPicPr>
             <a:picLocks noChangeAspect="1"/>
           </p:cNvPicPr>
@@ -7328,8 +7518,8 @@
         </p:blipFill>
         <p:spPr>
           <a:xfrm>
-            <a:off x="5897880" y="1874519"/>
-            <a:ext cx="5394960" cy="2355026"/>
+            <a:off x="5760720" y="2280719"/>
+            <a:ext cx="5669280" cy="2931361"/>
           </a:xfrm>
           <a:prstGeom prst="rect">
             <a:avLst/>
@@ -7345,7 +7535,7 @@
 </file>
 
 <file path=ppt/slides/slide7.xml><?xml version="1.0" encoding="utf-8"?>
-<p:sld xmlns:a="http://schemas.openxmlformats.org/drawingml/2006/main" xmlns:p="http://schemas.openxmlformats.org/presentationml/2006/main" xmlns:r="http://schemas.openxmlformats.org/officeDocument/2006/relationships">
+<p:sld xmlns:a="http://schemas.openxmlformats.org/drawingml/2006/main" xmlns:r="http://schemas.openxmlformats.org/officeDocument/2006/relationships" xmlns:p="http://schemas.openxmlformats.org/presentationml/2006/main">
   <p:cSld>
     <p:spTree>
       <p:nvGrpSpPr>
@@ -7353,7 +7543,14 @@
         <p:cNvGrpSpPr/>
         <p:nvPr/>
       </p:nvGrpSpPr>
-      <p:grpSpPr/>
+      <p:grpSpPr>
+        <a:xfrm>
+          <a:off x="0" y="0"/>
+          <a:ext cx="0" cy="0"/>
+          <a:chOff x="0" y="0"/>
+          <a:chExt cx="0" cy="0"/>
+        </a:xfrm>
+      </p:grpSpPr>
       <p:sp>
         <p:nvSpPr>
           <p:cNvPr id="2" name="TextBox 1"/>
@@ -7468,6 +7665,7 @@
           <a:lstStyle/>
           <a:p>
             <a:pPr algn="ctr"/>
+            <a:endParaRPr/>
           </a:p>
         </p:txBody>
       </p:sp>
@@ -7513,6 +7711,7 @@
           <a:lstStyle/>
           <a:p>
             <a:pPr algn="ctr"/>
+            <a:endParaRPr/>
           </a:p>
         </p:txBody>
       </p:sp>
@@ -7714,6 +7913,7 @@
           <a:lstStyle/>
           <a:p>
             <a:pPr algn="ctr"/>
+            <a:endParaRPr/>
           </a:p>
         </p:txBody>
       </p:sp>
@@ -7733,8 +7933,38 @@
         </p:blipFill>
         <p:spPr>
           <a:xfrm>
-            <a:off x="6080760" y="2011680"/>
+            <a:off x="5897880" y="584835"/>
             <a:ext cx="5212080" cy="3231490"/>
+          </a:xfrm>
+          <a:prstGeom prst="rect">
+            <a:avLst/>
+          </a:prstGeom>
+        </p:spPr>
+      </p:pic>
+      <p:pic>
+        <p:nvPicPr>
+          <p:cNvPr id="10" name="Picture 9">
+            <a:extLst>
+              <a:ext uri="{FF2B5EF4-FFF2-40B4-BE49-F238E27FC236}">
+                <a16:creationId xmlns:a16="http://schemas.microsoft.com/office/drawing/2014/main" id="{DEB5341B-1C71-6C95-AD6E-3710A753F23A}"/>
+              </a:ext>
+            </a:extLst>
+          </p:cNvPr>
+          <p:cNvPicPr>
+            <a:picLocks noChangeAspect="1"/>
+          </p:cNvPicPr>
+          <p:nvPr/>
+        </p:nvPicPr>
+        <p:blipFill>
+          <a:blip r:embed="rId3"/>
+          <a:stretch>
+            <a:fillRect/>
+          </a:stretch>
+        </p:blipFill>
+        <p:spPr>
+          <a:xfrm>
+            <a:off x="1643434" y="3977640"/>
+            <a:ext cx="8326012" cy="1333686"/>
           </a:xfrm>
           <a:prstGeom prst="rect">
             <a:avLst/>
@@ -7750,7 +7980,7 @@
 </file>
 
 <file path=ppt/slides/slide8.xml><?xml version="1.0" encoding="utf-8"?>
-<p:sld xmlns:a="http://schemas.openxmlformats.org/drawingml/2006/main" xmlns:p="http://schemas.openxmlformats.org/presentationml/2006/main" xmlns:r="http://schemas.openxmlformats.org/officeDocument/2006/relationships">
+<p:sld xmlns:a="http://schemas.openxmlformats.org/drawingml/2006/main" xmlns:r="http://schemas.openxmlformats.org/officeDocument/2006/relationships" xmlns:p="http://schemas.openxmlformats.org/presentationml/2006/main">
   <p:cSld>
     <p:spTree>
       <p:nvGrpSpPr>
@@ -7758,7 +7988,14 @@
         <p:cNvGrpSpPr/>
         <p:nvPr/>
       </p:nvGrpSpPr>
-      <p:grpSpPr/>
+      <p:grpSpPr>
+        <a:xfrm>
+          <a:off x="0" y="0"/>
+          <a:ext cx="0" cy="0"/>
+          <a:chOff x="0" y="0"/>
+          <a:chExt cx="0" cy="0"/>
+        </a:xfrm>
+      </p:grpSpPr>
       <p:sp>
         <p:nvSpPr>
           <p:cNvPr id="2" name="TextBox 1"/>
@@ -7873,6 +8110,7 @@
           <a:lstStyle/>
           <a:p>
             <a:pPr algn="ctr"/>
+            <a:endParaRPr/>
           </a:p>
         </p:txBody>
       </p:sp>
@@ -7918,6 +8156,7 @@
           <a:lstStyle/>
           <a:p>
             <a:pPr algn="ctr"/>
+            <a:endParaRPr/>
           </a:p>
         </p:txBody>
       </p:sp>
@@ -8143,6 +8382,7 @@
           <a:lstStyle/>
           <a:p>
             <a:pPr algn="ctr"/>
+            <a:endParaRPr/>
           </a:p>
         </p:txBody>
       </p:sp>
@@ -8179,7 +8419,7 @@
 </file>
 
 <file path=ppt/slides/slide9.xml><?xml version="1.0" encoding="utf-8"?>
-<p:sld xmlns:a="http://schemas.openxmlformats.org/drawingml/2006/main" xmlns:p="http://schemas.openxmlformats.org/presentationml/2006/main" xmlns:r="http://schemas.openxmlformats.org/officeDocument/2006/relationships">
+<p:sld xmlns:a="http://schemas.openxmlformats.org/drawingml/2006/main" xmlns:r="http://schemas.openxmlformats.org/officeDocument/2006/relationships" xmlns:p="http://schemas.openxmlformats.org/presentationml/2006/main">
   <p:cSld>
     <p:spTree>
       <p:nvGrpSpPr>
@@ -8187,7 +8427,14 @@
         <p:cNvGrpSpPr/>
         <p:nvPr/>
       </p:nvGrpSpPr>
-      <p:grpSpPr/>
+      <p:grpSpPr>
+        <a:xfrm>
+          <a:off x="0" y="0"/>
+          <a:ext cx="0" cy="0"/>
+          <a:chOff x="0" y="0"/>
+          <a:chExt cx="0" cy="0"/>
+        </a:xfrm>
+      </p:grpSpPr>
       <p:sp>
         <p:nvSpPr>
           <p:cNvPr id="2" name="TextBox 1"/>
@@ -8302,6 +8549,7 @@
           <a:lstStyle/>
           <a:p>
             <a:pPr algn="ctr"/>
+            <a:endParaRPr/>
           </a:p>
         </p:txBody>
       </p:sp>
@@ -8347,6 +8595,7 @@
           <a:lstStyle/>
           <a:p>
             <a:pPr algn="ctr"/>
+            <a:endParaRPr/>
           </a:p>
         </p:txBody>
       </p:sp>
@@ -8548,12 +8797,19 @@
           <a:lstStyle/>
           <a:p>
             <a:pPr algn="ctr"/>
+            <a:endParaRPr/>
           </a:p>
         </p:txBody>
       </p:sp>
       <p:pic>
         <p:nvPicPr>
-          <p:cNvPr id="8" name="Picture 7" descr="telegram_notification.png"/>
+          <p:cNvPr id="10" name="Picture 9">
+            <a:extLst>
+              <a:ext uri="{FF2B5EF4-FFF2-40B4-BE49-F238E27FC236}">
+                <a16:creationId xmlns:a16="http://schemas.microsoft.com/office/drawing/2014/main" id="{AE7A94BB-38F3-BA23-E39F-09AE0562E8CE}"/>
+              </a:ext>
+            </a:extLst>
+          </p:cNvPr>
           <p:cNvPicPr>
             <a:picLocks noChangeAspect="1"/>
           </p:cNvPicPr>
@@ -8567,8 +8823,8 @@
         </p:blipFill>
         <p:spPr>
           <a:xfrm>
-            <a:off x="6080760" y="2011680"/>
-            <a:ext cx="5212080" cy="4039362"/>
+            <a:off x="6511400" y="2209800"/>
+            <a:ext cx="4071143" cy="3164205"/>
           </a:xfrm>
           <a:prstGeom prst="rect">
             <a:avLst/>

</xml_diff>

<commit_message>
feat: align backend service name to cicd-assignment-backend and update active cluster IP in slides and docs
</commit_message>
<xml_diff>
--- a/Assignment.pptx
+++ b/Assignment.pptx
@@ -5,20 +5,20 @@
     <p:sldMasterId id="2147483648" r:id="rId1"/>
   </p:sldMasterIdLst>
   <p:sldIdLst>
-    <p:sldId id="256" r:id="rId2"/>
-    <p:sldId id="257" r:id="rId3"/>
-    <p:sldId id="258" r:id="rId4"/>
-    <p:sldId id="259" r:id="rId5"/>
-    <p:sldId id="260" r:id="rId6"/>
-    <p:sldId id="261" r:id="rId7"/>
-    <p:sldId id="262" r:id="rId8"/>
-    <p:sldId id="263" r:id="rId9"/>
-    <p:sldId id="264" r:id="rId10"/>
-    <p:sldId id="265" r:id="rId11"/>
-    <p:sldId id="266" r:id="rId12"/>
-    <p:sldId id="267" r:id="rId13"/>
+    <p:sldId id="256" r:id="rId7"/>
+    <p:sldId id="257" r:id="rId8"/>
+    <p:sldId id="258" r:id="rId9"/>
+    <p:sldId id="259" r:id="rId10"/>
+    <p:sldId id="260" r:id="rId11"/>
+    <p:sldId id="261" r:id="rId12"/>
+    <p:sldId id="262" r:id="rId13"/>
+    <p:sldId id="263" r:id="rId14"/>
+    <p:sldId id="264" r:id="rId15"/>
+    <p:sldId id="265" r:id="rId16"/>
+    <p:sldId id="266" r:id="rId17"/>
+    <p:sldId id="267" r:id="rId18"/>
   </p:sldIdLst>
-  <p:sldSz cx="12192000" cy="6858000"/>
+  <p:sldSz cx="12191695" cy="6858000" type="screen4x3"/>
   <p:notesSz cx="6858000" cy="9144000"/>
   <p:defaultTextStyle>
     <a:defPPr>
@@ -115,22 +115,6 @@
       </a:defRPr>
     </a:lvl9pPr>
   </p:defaultTextStyle>
-  <p:extLst>
-    <p:ext uri="{EFAFB233-063F-42B5-8137-9DF3F51BA10A}">
-      <p15:sldGuideLst xmlns:p15="http://schemas.microsoft.com/office/powerpoint/2012/main">
-        <p15:guide id="1" orient="horz" pos="2160">
-          <p15:clr>
-            <a:srgbClr val="A4A3A4"/>
-          </p15:clr>
-        </p15:guide>
-        <p15:guide id="2" pos="2880">
-          <p15:clr>
-            <a:srgbClr val="A4A3A4"/>
-          </p15:clr>
-        </p15:guide>
-      </p15:sldGuideLst>
-    </p:ext>
-  </p:extLst>
 </p:presentation>
 </file>
 
@@ -172,9 +156,10 @@
           <a:lstStyle/>
           <a:p>
             <a:r>
-              <a:rPr lang="en-US"/>
+              <a:rPr lang="en-US" smtClean="0"/>
               <a:t>Click to edit Master title style</a:t>
             </a:r>
+            <a:endParaRPr lang="en-US"/>
           </a:p>
         </p:txBody>
       </p:sp>
@@ -290,9 +275,10 @@
           </a:lstStyle>
           <a:p>
             <a:r>
-              <a:rPr lang="en-US"/>
+              <a:rPr lang="en-US" smtClean="0"/>
               <a:t>Click to edit Master subtitle style</a:t>
             </a:r>
+            <a:endParaRPr lang="en-US"/>
           </a:p>
         </p:txBody>
       </p:sp>
@@ -313,7 +299,7 @@
           <a:p>
             <a:fld id="{5BCAD085-E8A6-8845-BD4E-CB4CCA059FC4}" type="datetimeFigureOut">
               <a:rPr lang="en-US" smtClean="0"/>
-              <a:t>10/29/2026</a:t>
+              <a:t>1/27/13</a:t>
             </a:fld>
             <a:endParaRPr lang="en-US"/>
           </a:p>
@@ -407,9 +393,10 @@
           <a:lstStyle/>
           <a:p>
             <a:r>
-              <a:rPr lang="en-US"/>
+              <a:rPr lang="en-US" smtClean="0"/>
               <a:t>Click to edit Master title style</a:t>
             </a:r>
+            <a:endParaRPr lang="en-US"/>
           </a:p>
         </p:txBody>
       </p:sp>
@@ -430,37 +417,38 @@
           <a:p>
             <a:pPr lvl="0"/>
             <a:r>
-              <a:rPr lang="en-US"/>
+              <a:rPr lang="en-US" smtClean="0"/>
               <a:t>Click to edit Master text styles</a:t>
             </a:r>
           </a:p>
           <a:p>
             <a:pPr lvl="1"/>
             <a:r>
-              <a:rPr lang="en-US"/>
+              <a:rPr lang="en-US" smtClean="0"/>
               <a:t>Second level</a:t>
             </a:r>
           </a:p>
           <a:p>
             <a:pPr lvl="2"/>
             <a:r>
-              <a:rPr lang="en-US"/>
+              <a:rPr lang="en-US" smtClean="0"/>
               <a:t>Third level</a:t>
             </a:r>
           </a:p>
           <a:p>
             <a:pPr lvl="3"/>
             <a:r>
-              <a:rPr lang="en-US"/>
+              <a:rPr lang="en-US" smtClean="0"/>
               <a:t>Fourth level</a:t>
             </a:r>
           </a:p>
           <a:p>
             <a:pPr lvl="4"/>
             <a:r>
-              <a:rPr lang="en-US"/>
+              <a:rPr lang="en-US" smtClean="0"/>
               <a:t>Fifth level</a:t>
             </a:r>
+            <a:endParaRPr lang="en-US"/>
           </a:p>
         </p:txBody>
       </p:sp>
@@ -481,7 +469,7 @@
           <a:p>
             <a:fld id="{5BCAD085-E8A6-8845-BD4E-CB4CCA059FC4}" type="datetimeFigureOut">
               <a:rPr lang="en-US" smtClean="0"/>
-              <a:t>10/29/2026</a:t>
+              <a:t>1/27/13</a:t>
             </a:fld>
             <a:endParaRPr lang="en-US"/>
           </a:p>
@@ -580,9 +568,10 @@
           <a:lstStyle/>
           <a:p>
             <a:r>
-              <a:rPr lang="en-US"/>
+              <a:rPr lang="en-US" smtClean="0"/>
               <a:t>Click to edit Master title style</a:t>
             </a:r>
+            <a:endParaRPr lang="en-US"/>
           </a:p>
         </p:txBody>
       </p:sp>
@@ -608,37 +597,38 @@
           <a:p>
             <a:pPr lvl="0"/>
             <a:r>
-              <a:rPr lang="en-US"/>
+              <a:rPr lang="en-US" smtClean="0"/>
               <a:t>Click to edit Master text styles</a:t>
             </a:r>
           </a:p>
           <a:p>
             <a:pPr lvl="1"/>
             <a:r>
-              <a:rPr lang="en-US"/>
+              <a:rPr lang="en-US" smtClean="0"/>
               <a:t>Second level</a:t>
             </a:r>
           </a:p>
           <a:p>
             <a:pPr lvl="2"/>
             <a:r>
-              <a:rPr lang="en-US"/>
+              <a:rPr lang="en-US" smtClean="0"/>
               <a:t>Third level</a:t>
             </a:r>
           </a:p>
           <a:p>
             <a:pPr lvl="3"/>
             <a:r>
-              <a:rPr lang="en-US"/>
+              <a:rPr lang="en-US" smtClean="0"/>
               <a:t>Fourth level</a:t>
             </a:r>
           </a:p>
           <a:p>
             <a:pPr lvl="4"/>
             <a:r>
-              <a:rPr lang="en-US"/>
+              <a:rPr lang="en-US" smtClean="0"/>
               <a:t>Fifth level</a:t>
             </a:r>
+            <a:endParaRPr lang="en-US"/>
           </a:p>
         </p:txBody>
       </p:sp>
@@ -659,7 +649,7 @@
           <a:p>
             <a:fld id="{5BCAD085-E8A6-8845-BD4E-CB4CCA059FC4}" type="datetimeFigureOut">
               <a:rPr lang="en-US" smtClean="0"/>
-              <a:t>10/29/2026</a:t>
+              <a:t>1/27/13</a:t>
             </a:fld>
             <a:endParaRPr lang="en-US"/>
           </a:p>
@@ -753,9 +743,10 @@
           <a:lstStyle/>
           <a:p>
             <a:r>
-              <a:rPr lang="en-US"/>
+              <a:rPr lang="en-US" smtClean="0"/>
               <a:t>Click to edit Master title style</a:t>
             </a:r>
+            <a:endParaRPr lang="en-US"/>
           </a:p>
         </p:txBody>
       </p:sp>
@@ -776,37 +767,38 @@
           <a:p>
             <a:pPr lvl="0"/>
             <a:r>
-              <a:rPr lang="en-US"/>
+              <a:rPr lang="en-US" smtClean="0"/>
               <a:t>Click to edit Master text styles</a:t>
             </a:r>
           </a:p>
           <a:p>
             <a:pPr lvl="1"/>
             <a:r>
-              <a:rPr lang="en-US"/>
+              <a:rPr lang="en-US" smtClean="0"/>
               <a:t>Second level</a:t>
             </a:r>
           </a:p>
           <a:p>
             <a:pPr lvl="2"/>
             <a:r>
-              <a:rPr lang="en-US"/>
+              <a:rPr lang="en-US" smtClean="0"/>
               <a:t>Third level</a:t>
             </a:r>
           </a:p>
           <a:p>
             <a:pPr lvl="3"/>
             <a:r>
-              <a:rPr lang="en-US"/>
+              <a:rPr lang="en-US" smtClean="0"/>
               <a:t>Fourth level</a:t>
             </a:r>
           </a:p>
           <a:p>
             <a:pPr lvl="4"/>
             <a:r>
-              <a:rPr lang="en-US"/>
+              <a:rPr lang="en-US" smtClean="0"/>
               <a:t>Fifth level</a:t>
             </a:r>
+            <a:endParaRPr lang="en-US"/>
           </a:p>
         </p:txBody>
       </p:sp>
@@ -827,7 +819,7 @@
           <a:p>
             <a:fld id="{5BCAD085-E8A6-8845-BD4E-CB4CCA059FC4}" type="datetimeFigureOut">
               <a:rPr lang="en-US" smtClean="0"/>
-              <a:t>10/29/2026</a:t>
+              <a:t>1/27/13</a:t>
             </a:fld>
             <a:endParaRPr lang="en-US"/>
           </a:p>
@@ -930,9 +922,10 @@
           </a:lstStyle>
           <a:p>
             <a:r>
-              <a:rPr lang="en-US"/>
+              <a:rPr lang="en-US" smtClean="0"/>
               <a:t>Click to edit Master title style</a:t>
             </a:r>
+            <a:endParaRPr lang="en-US"/>
           </a:p>
         </p:txBody>
       </p:sp>
@@ -1049,7 +1042,7 @@
           <a:p>
             <a:pPr lvl="0"/>
             <a:r>
-              <a:rPr lang="en-US"/>
+              <a:rPr lang="en-US" smtClean="0"/>
               <a:t>Click to edit Master text styles</a:t>
             </a:r>
           </a:p>
@@ -1072,7 +1065,7 @@
           <a:p>
             <a:fld id="{5BCAD085-E8A6-8845-BD4E-CB4CCA059FC4}" type="datetimeFigureOut">
               <a:rPr lang="en-US" smtClean="0"/>
-              <a:t>10/29/2026</a:t>
+              <a:t>1/27/13</a:t>
             </a:fld>
             <a:endParaRPr lang="en-US"/>
           </a:p>
@@ -1166,9 +1159,10 @@
           <a:lstStyle/>
           <a:p>
             <a:r>
-              <a:rPr lang="en-US"/>
+              <a:rPr lang="en-US" smtClean="0"/>
               <a:t>Click to edit Master title style</a:t>
             </a:r>
+            <a:endParaRPr lang="en-US"/>
           </a:p>
         </p:txBody>
       </p:sp>
@@ -1222,37 +1216,38 @@
           <a:p>
             <a:pPr lvl="0"/>
             <a:r>
-              <a:rPr lang="en-US"/>
+              <a:rPr lang="en-US" smtClean="0"/>
               <a:t>Click to edit Master text styles</a:t>
             </a:r>
           </a:p>
           <a:p>
             <a:pPr lvl="1"/>
             <a:r>
-              <a:rPr lang="en-US"/>
+              <a:rPr lang="en-US" smtClean="0"/>
               <a:t>Second level</a:t>
             </a:r>
           </a:p>
           <a:p>
             <a:pPr lvl="2"/>
             <a:r>
-              <a:rPr lang="en-US"/>
+              <a:rPr lang="en-US" smtClean="0"/>
               <a:t>Third level</a:t>
             </a:r>
           </a:p>
           <a:p>
             <a:pPr lvl="3"/>
             <a:r>
-              <a:rPr lang="en-US"/>
+              <a:rPr lang="en-US" smtClean="0"/>
               <a:t>Fourth level</a:t>
             </a:r>
           </a:p>
           <a:p>
             <a:pPr lvl="4"/>
             <a:r>
-              <a:rPr lang="en-US"/>
+              <a:rPr lang="en-US" smtClean="0"/>
               <a:t>Fifth level</a:t>
             </a:r>
+            <a:endParaRPr lang="en-US"/>
           </a:p>
         </p:txBody>
       </p:sp>
@@ -1306,37 +1301,38 @@
           <a:p>
             <a:pPr lvl="0"/>
             <a:r>
-              <a:rPr lang="en-US"/>
+              <a:rPr lang="en-US" smtClean="0"/>
               <a:t>Click to edit Master text styles</a:t>
             </a:r>
           </a:p>
           <a:p>
             <a:pPr lvl="1"/>
             <a:r>
-              <a:rPr lang="en-US"/>
+              <a:rPr lang="en-US" smtClean="0"/>
               <a:t>Second level</a:t>
             </a:r>
           </a:p>
           <a:p>
             <a:pPr lvl="2"/>
             <a:r>
-              <a:rPr lang="en-US"/>
+              <a:rPr lang="en-US" smtClean="0"/>
               <a:t>Third level</a:t>
             </a:r>
           </a:p>
           <a:p>
             <a:pPr lvl="3"/>
             <a:r>
-              <a:rPr lang="en-US"/>
+              <a:rPr lang="en-US" smtClean="0"/>
               <a:t>Fourth level</a:t>
             </a:r>
           </a:p>
           <a:p>
             <a:pPr lvl="4"/>
             <a:r>
-              <a:rPr lang="en-US"/>
+              <a:rPr lang="en-US" smtClean="0"/>
               <a:t>Fifth level</a:t>
             </a:r>
+            <a:endParaRPr lang="en-US"/>
           </a:p>
         </p:txBody>
       </p:sp>
@@ -1357,7 +1353,7 @@
           <a:p>
             <a:fld id="{5BCAD085-E8A6-8845-BD4E-CB4CCA059FC4}" type="datetimeFigureOut">
               <a:rPr lang="en-US" smtClean="0"/>
-              <a:t>10/29/2026</a:t>
+              <a:t>1/27/13</a:t>
             </a:fld>
             <a:endParaRPr lang="en-US"/>
           </a:p>
@@ -1455,9 +1451,10 @@
           </a:lstStyle>
           <a:p>
             <a:r>
-              <a:rPr lang="en-US"/>
+              <a:rPr lang="en-US" smtClean="0"/>
               <a:t>Click to edit Master title style</a:t>
             </a:r>
+            <a:endParaRPr lang="en-US"/>
           </a:p>
         </p:txBody>
       </p:sp>
@@ -1520,7 +1517,7 @@
           <a:p>
             <a:pPr lvl="0"/>
             <a:r>
-              <a:rPr lang="en-US"/>
+              <a:rPr lang="en-US" smtClean="0"/>
               <a:t>Click to edit Master text styles</a:t>
             </a:r>
           </a:p>
@@ -1576,37 +1573,38 @@
           <a:p>
             <a:pPr lvl="0"/>
             <a:r>
-              <a:rPr lang="en-US"/>
+              <a:rPr lang="en-US" smtClean="0"/>
               <a:t>Click to edit Master text styles</a:t>
             </a:r>
           </a:p>
           <a:p>
             <a:pPr lvl="1"/>
             <a:r>
-              <a:rPr lang="en-US"/>
+              <a:rPr lang="en-US" smtClean="0"/>
               <a:t>Second level</a:t>
             </a:r>
           </a:p>
           <a:p>
             <a:pPr lvl="2"/>
             <a:r>
-              <a:rPr lang="en-US"/>
+              <a:rPr lang="en-US" smtClean="0"/>
               <a:t>Third level</a:t>
             </a:r>
           </a:p>
           <a:p>
             <a:pPr lvl="3"/>
             <a:r>
-              <a:rPr lang="en-US"/>
+              <a:rPr lang="en-US" smtClean="0"/>
               <a:t>Fourth level</a:t>
             </a:r>
           </a:p>
           <a:p>
             <a:pPr lvl="4"/>
             <a:r>
-              <a:rPr lang="en-US"/>
+              <a:rPr lang="en-US" smtClean="0"/>
               <a:t>Fifth level</a:t>
             </a:r>
+            <a:endParaRPr lang="en-US"/>
           </a:p>
         </p:txBody>
       </p:sp>
@@ -1669,7 +1667,7 @@
           <a:p>
             <a:pPr lvl="0"/>
             <a:r>
-              <a:rPr lang="en-US"/>
+              <a:rPr lang="en-US" smtClean="0"/>
               <a:t>Click to edit Master text styles</a:t>
             </a:r>
           </a:p>
@@ -1725,37 +1723,38 @@
           <a:p>
             <a:pPr lvl="0"/>
             <a:r>
-              <a:rPr lang="en-US"/>
+              <a:rPr lang="en-US" smtClean="0"/>
               <a:t>Click to edit Master text styles</a:t>
             </a:r>
           </a:p>
           <a:p>
             <a:pPr lvl="1"/>
             <a:r>
-              <a:rPr lang="en-US"/>
+              <a:rPr lang="en-US" smtClean="0"/>
               <a:t>Second level</a:t>
             </a:r>
           </a:p>
           <a:p>
             <a:pPr lvl="2"/>
             <a:r>
-              <a:rPr lang="en-US"/>
+              <a:rPr lang="en-US" smtClean="0"/>
               <a:t>Third level</a:t>
             </a:r>
           </a:p>
           <a:p>
             <a:pPr lvl="3"/>
             <a:r>
-              <a:rPr lang="en-US"/>
+              <a:rPr lang="en-US" smtClean="0"/>
               <a:t>Fourth level</a:t>
             </a:r>
           </a:p>
           <a:p>
             <a:pPr lvl="4"/>
             <a:r>
-              <a:rPr lang="en-US"/>
+              <a:rPr lang="en-US" smtClean="0"/>
               <a:t>Fifth level</a:t>
             </a:r>
+            <a:endParaRPr lang="en-US"/>
           </a:p>
         </p:txBody>
       </p:sp>
@@ -1776,7 +1775,7 @@
           <a:p>
             <a:fld id="{5BCAD085-E8A6-8845-BD4E-CB4CCA059FC4}" type="datetimeFigureOut">
               <a:rPr lang="en-US" smtClean="0"/>
-              <a:t>10/29/2026</a:t>
+              <a:t>1/27/13</a:t>
             </a:fld>
             <a:endParaRPr lang="en-US"/>
           </a:p>
@@ -1870,9 +1869,10 @@
           <a:lstStyle/>
           <a:p>
             <a:r>
-              <a:rPr lang="en-US"/>
+              <a:rPr lang="en-US" smtClean="0"/>
               <a:t>Click to edit Master title style</a:t>
             </a:r>
+            <a:endParaRPr lang="en-US"/>
           </a:p>
         </p:txBody>
       </p:sp>
@@ -1893,7 +1893,7 @@
           <a:p>
             <a:fld id="{5BCAD085-E8A6-8845-BD4E-CB4CCA059FC4}" type="datetimeFigureOut">
               <a:rPr lang="en-US" smtClean="0"/>
-              <a:t>10/29/2026</a:t>
+              <a:t>1/27/13</a:t>
             </a:fld>
             <a:endParaRPr lang="en-US"/>
           </a:p>
@@ -1988,7 +1988,7 @@
           <a:p>
             <a:fld id="{5BCAD085-E8A6-8845-BD4E-CB4CCA059FC4}" type="datetimeFigureOut">
               <a:rPr lang="en-US" smtClean="0"/>
-              <a:t>10/29/2026</a:t>
+              <a:t>1/27/13</a:t>
             </a:fld>
             <a:endParaRPr lang="en-US"/>
           </a:p>
@@ -2091,9 +2091,10 @@
           </a:lstStyle>
           <a:p>
             <a:r>
-              <a:rPr lang="en-US"/>
+              <a:rPr lang="en-US" smtClean="0"/>
               <a:t>Click to edit Master title style</a:t>
             </a:r>
+            <a:endParaRPr lang="en-US"/>
           </a:p>
         </p:txBody>
       </p:sp>
@@ -2147,37 +2148,38 @@
           <a:p>
             <a:pPr lvl="0"/>
             <a:r>
-              <a:rPr lang="en-US"/>
+              <a:rPr lang="en-US" smtClean="0"/>
               <a:t>Click to edit Master text styles</a:t>
             </a:r>
           </a:p>
           <a:p>
             <a:pPr lvl="1"/>
             <a:r>
-              <a:rPr lang="en-US"/>
+              <a:rPr lang="en-US" smtClean="0"/>
               <a:t>Second level</a:t>
             </a:r>
           </a:p>
           <a:p>
             <a:pPr lvl="2"/>
             <a:r>
-              <a:rPr lang="en-US"/>
+              <a:rPr lang="en-US" smtClean="0"/>
               <a:t>Third level</a:t>
             </a:r>
           </a:p>
           <a:p>
             <a:pPr lvl="3"/>
             <a:r>
-              <a:rPr lang="en-US"/>
+              <a:rPr lang="en-US" smtClean="0"/>
               <a:t>Fourth level</a:t>
             </a:r>
           </a:p>
           <a:p>
             <a:pPr lvl="4"/>
             <a:r>
-              <a:rPr lang="en-US"/>
+              <a:rPr lang="en-US" smtClean="0"/>
               <a:t>Fifth level</a:t>
             </a:r>
+            <a:endParaRPr lang="en-US"/>
           </a:p>
         </p:txBody>
       </p:sp>
@@ -2240,7 +2242,7 @@
           <a:p>
             <a:pPr lvl="0"/>
             <a:r>
-              <a:rPr lang="en-US"/>
+              <a:rPr lang="en-US" smtClean="0"/>
               <a:t>Click to edit Master text styles</a:t>
             </a:r>
           </a:p>
@@ -2263,7 +2265,7 @@
           <a:p>
             <a:fld id="{5BCAD085-E8A6-8845-BD4E-CB4CCA059FC4}" type="datetimeFigureOut">
               <a:rPr lang="en-US" smtClean="0"/>
-              <a:t>10/29/2026</a:t>
+              <a:t>1/27/13</a:t>
             </a:fld>
             <a:endParaRPr lang="en-US"/>
           </a:p>
@@ -2366,9 +2368,10 @@
           </a:lstStyle>
           <a:p>
             <a:r>
-              <a:rPr lang="en-US"/>
+              <a:rPr lang="en-US" smtClean="0"/>
               <a:t>Click to edit Master title style</a:t>
             </a:r>
+            <a:endParaRPr lang="en-US"/>
           </a:p>
         </p:txBody>
       </p:sp>
@@ -2492,7 +2495,7 @@
           <a:p>
             <a:pPr lvl="0"/>
             <a:r>
-              <a:rPr lang="en-US"/>
+              <a:rPr lang="en-US" smtClean="0"/>
               <a:t>Click to edit Master text styles</a:t>
             </a:r>
           </a:p>
@@ -2515,7 +2518,7 @@
           <a:p>
             <a:fld id="{5BCAD085-E8A6-8845-BD4E-CB4CCA059FC4}" type="datetimeFigureOut">
               <a:rPr lang="en-US" smtClean="0"/>
-              <a:t>10/29/2026</a:t>
+              <a:t>1/27/13</a:t>
             </a:fld>
             <a:endParaRPr lang="en-US"/>
           </a:p>
@@ -2624,9 +2627,10 @@
           <a:lstStyle/>
           <a:p>
             <a:r>
-              <a:rPr lang="en-US"/>
+              <a:rPr lang="en-US" smtClean="0"/>
               <a:t>Click to edit Master title style</a:t>
             </a:r>
+            <a:endParaRPr lang="en-US"/>
           </a:p>
         </p:txBody>
       </p:sp>
@@ -2657,37 +2661,38 @@
           <a:p>
             <a:pPr lvl="0"/>
             <a:r>
-              <a:rPr lang="en-US"/>
+              <a:rPr lang="en-US" smtClean="0"/>
               <a:t>Click to edit Master text styles</a:t>
             </a:r>
           </a:p>
           <a:p>
             <a:pPr lvl="1"/>
             <a:r>
-              <a:rPr lang="en-US"/>
+              <a:rPr lang="en-US" smtClean="0"/>
               <a:t>Second level</a:t>
             </a:r>
           </a:p>
           <a:p>
             <a:pPr lvl="2"/>
             <a:r>
-              <a:rPr lang="en-US"/>
+              <a:rPr lang="en-US" smtClean="0"/>
               <a:t>Third level</a:t>
             </a:r>
           </a:p>
           <a:p>
             <a:pPr lvl="3"/>
             <a:r>
-              <a:rPr lang="en-US"/>
+              <a:rPr lang="en-US" smtClean="0"/>
               <a:t>Fourth level</a:t>
             </a:r>
           </a:p>
           <a:p>
             <a:pPr lvl="4"/>
             <a:r>
-              <a:rPr lang="en-US"/>
+              <a:rPr lang="en-US" smtClean="0"/>
               <a:t>Fifth level</a:t>
             </a:r>
+            <a:endParaRPr lang="en-US"/>
           </a:p>
         </p:txBody>
       </p:sp>
@@ -2726,7 +2731,7 @@
           <a:p>
             <a:fld id="{5BCAD085-E8A6-8845-BD4E-CB4CCA059FC4}" type="datetimeFigureOut">
               <a:rPr lang="en-US" smtClean="0"/>
-              <a:t>10/29/2026</a:t>
+              <a:t>1/27/13</a:t>
             </a:fld>
             <a:endParaRPr lang="en-US"/>
           </a:p>
@@ -3085,7 +3090,7 @@
 </file>
 
 <file path=ppt/slides/slide1.xml><?xml version="1.0" encoding="utf-8"?>
-<p:sld xmlns:a="http://schemas.openxmlformats.org/drawingml/2006/main" xmlns:r="http://schemas.openxmlformats.org/officeDocument/2006/relationships" xmlns:p="http://schemas.openxmlformats.org/presentationml/2006/main">
+<p:sld xmlns:a="http://schemas.openxmlformats.org/drawingml/2006/main" xmlns:p="http://schemas.openxmlformats.org/presentationml/2006/main" xmlns:r="http://schemas.openxmlformats.org/officeDocument/2006/relationships">
   <p:cSld>
     <p:spTree>
       <p:nvGrpSpPr>
@@ -3093,14 +3098,7 @@
         <p:cNvGrpSpPr/>
         <p:nvPr/>
       </p:nvGrpSpPr>
-      <p:grpSpPr>
-        <a:xfrm>
-          <a:off x="0" y="0"/>
-          <a:ext cx="0" cy="0"/>
-          <a:chOff x="0" y="0"/>
-          <a:chExt cx="0" cy="0"/>
-        </a:xfrm>
-      </p:grpSpPr>
+      <p:grpSpPr/>
       <p:sp>
         <p:nvSpPr>
           <p:cNvPr id="2" name="Rectangle 1"/>
@@ -3141,7 +3139,6 @@
           <a:lstStyle/>
           <a:p>
             <a:pPr algn="ctr"/>
-            <a:endParaRPr/>
           </a:p>
         </p:txBody>
       </p:sp>
@@ -3187,7 +3184,6 @@
           <a:lstStyle/>
           <a:p>
             <a:pPr algn="ctr"/>
-            <a:endParaRPr/>
           </a:p>
         </p:txBody>
       </p:sp>
@@ -3354,7 +3350,7 @@
               </a:defRPr>
             </a:pPr>
             <a:r>
-              <a:t>Verification: Jenkins Pipeline #4 Passed  |  Live Cluster IP: 54.253.170.114  |  October 2026</a:t>
+              <a:t>Verification: Jenkins Pipeline #4 Passed  |  Live Cluster IP: 3.104.55.68  |  October 2026</a:t>
             </a:r>
           </a:p>
         </p:txBody>
@@ -3368,7 +3364,7 @@
 </file>
 
 <file path=ppt/slides/slide10.xml><?xml version="1.0" encoding="utf-8"?>
-<p:sld xmlns:a="http://schemas.openxmlformats.org/drawingml/2006/main" xmlns:r="http://schemas.openxmlformats.org/officeDocument/2006/relationships" xmlns:p="http://schemas.openxmlformats.org/presentationml/2006/main">
+<p:sld xmlns:a="http://schemas.openxmlformats.org/drawingml/2006/main" xmlns:p="http://schemas.openxmlformats.org/presentationml/2006/main" xmlns:r="http://schemas.openxmlformats.org/officeDocument/2006/relationships">
   <p:cSld>
     <p:spTree>
       <p:nvGrpSpPr>
@@ -3376,14 +3372,7 @@
         <p:cNvGrpSpPr/>
         <p:nvPr/>
       </p:nvGrpSpPr>
-      <p:grpSpPr>
-        <a:xfrm>
-          <a:off x="0" y="0"/>
-          <a:ext cx="0" cy="0"/>
-          <a:chOff x="0" y="0"/>
-          <a:chExt cx="0" cy="0"/>
-        </a:xfrm>
-      </p:grpSpPr>
+      <p:grpSpPr/>
       <p:sp>
         <p:nvSpPr>
           <p:cNvPr id="2" name="TextBox 1"/>
@@ -3498,7 +3487,6 @@
           <a:lstStyle/>
           <a:p>
             <a:pPr algn="ctr"/>
-            <a:endParaRPr/>
           </a:p>
         </p:txBody>
       </p:sp>
@@ -3544,7 +3532,6 @@
           <a:lstStyle/>
           <a:p>
             <a:pPr algn="ctr"/>
-            <a:endParaRPr/>
           </a:p>
         </p:txBody>
       </p:sp>
@@ -3587,7 +3574,7 @@
               <a:spcAft>
                 <a:spcPts val="200"/>
               </a:spcAft>
-              <a:defRPr sz="950" b="1">
+              <a:defRPr b="1" sz="950">
                 <a:solidFill>
                   <a:srgbClr val="DC2626"/>
                 </a:solidFill>
@@ -3607,7 +3594,7 @@
           </a:p>
           <a:p>
             <a:pPr>
-              <a:defRPr sz="950" b="1">
+              <a:defRPr b="1" sz="950">
                 <a:solidFill>
                   <a:srgbClr val="16A34A"/>
                 </a:solidFill>
@@ -3669,7 +3656,6 @@
           <a:lstStyle/>
           <a:p>
             <a:pPr algn="ctr"/>
-            <a:endParaRPr/>
           </a:p>
         </p:txBody>
       </p:sp>
@@ -3712,7 +3698,7 @@
               <a:spcAft>
                 <a:spcPts val="200"/>
               </a:spcAft>
-              <a:defRPr sz="950" b="1">
+              <a:defRPr b="1" sz="950">
                 <a:solidFill>
                   <a:srgbClr val="DC2626"/>
                 </a:solidFill>
@@ -3732,7 +3718,7 @@
           </a:p>
           <a:p>
             <a:pPr>
-              <a:defRPr sz="950" b="1">
+              <a:defRPr b="1" sz="950">
                 <a:solidFill>
                   <a:srgbClr val="16A34A"/>
                 </a:solidFill>
@@ -3794,7 +3780,6 @@
           <a:lstStyle/>
           <a:p>
             <a:pPr algn="ctr"/>
-            <a:endParaRPr/>
           </a:p>
         </p:txBody>
       </p:sp>
@@ -3837,7 +3822,7 @@
               <a:spcAft>
                 <a:spcPts val="200"/>
               </a:spcAft>
-              <a:defRPr sz="950" b="1">
+              <a:defRPr b="1" sz="950">
                 <a:solidFill>
                   <a:srgbClr val="DC2626"/>
                 </a:solidFill>
@@ -3857,7 +3842,7 @@
           </a:p>
           <a:p>
             <a:pPr>
-              <a:defRPr sz="950" b="1">
+              <a:defRPr b="1" sz="950">
                 <a:solidFill>
                   <a:srgbClr val="16A34A"/>
                 </a:solidFill>
@@ -3919,7 +3904,6 @@
           <a:lstStyle/>
           <a:p>
             <a:pPr algn="ctr"/>
-            <a:endParaRPr/>
           </a:p>
         </p:txBody>
       </p:sp>
@@ -3962,7 +3946,7 @@
               <a:spcAft>
                 <a:spcPts val="200"/>
               </a:spcAft>
-              <a:defRPr sz="950" b="1">
+              <a:defRPr b="1" sz="950">
                 <a:solidFill>
                   <a:srgbClr val="DC2626"/>
                 </a:solidFill>
@@ -3982,7 +3966,7 @@
           </a:p>
           <a:p>
             <a:pPr>
-              <a:defRPr sz="950" b="1">
+              <a:defRPr b="1" sz="950">
                 <a:solidFill>
                   <a:srgbClr val="16A34A"/>
                 </a:solidFill>
@@ -4011,7 +3995,7 @@
 </file>
 
 <file path=ppt/slides/slide11.xml><?xml version="1.0" encoding="utf-8"?>
-<p:sld xmlns:a="http://schemas.openxmlformats.org/drawingml/2006/main" xmlns:r="http://schemas.openxmlformats.org/officeDocument/2006/relationships" xmlns:p="http://schemas.openxmlformats.org/presentationml/2006/main">
+<p:sld xmlns:a="http://schemas.openxmlformats.org/drawingml/2006/main" xmlns:p="http://schemas.openxmlformats.org/presentationml/2006/main" xmlns:r="http://schemas.openxmlformats.org/officeDocument/2006/relationships">
   <p:cSld>
     <p:spTree>
       <p:nvGrpSpPr>
@@ -4019,14 +4003,7 @@
         <p:cNvGrpSpPr/>
         <p:nvPr/>
       </p:nvGrpSpPr>
-      <p:grpSpPr>
-        <a:xfrm>
-          <a:off x="0" y="0"/>
-          <a:ext cx="0" cy="0"/>
-          <a:chOff x="0" y="0"/>
-          <a:chExt cx="0" cy="0"/>
-        </a:xfrm>
-      </p:grpSpPr>
+      <p:grpSpPr/>
       <p:sp>
         <p:nvSpPr>
           <p:cNvPr id="2" name="TextBox 1"/>
@@ -4141,7 +4118,6 @@
           <a:lstStyle/>
           <a:p>
             <a:pPr algn="ctr"/>
-            <a:endParaRPr/>
           </a:p>
         </p:txBody>
       </p:sp>
@@ -4187,7 +4163,6 @@
           <a:lstStyle/>
           <a:p>
             <a:pPr algn="ctr"/>
-            <a:endParaRPr/>
           </a:p>
         </p:txBody>
       </p:sp>
@@ -4238,7 +4213,7 @@
               </a:defRPr>
             </a:pPr>
             <a:r>
-              <a:t>•  Open browser: http://54.253.170.114</a:t>
+              <a:t>•  Open browser: http://3.104.55.68</a:t>
             </a:r>
           </a:p>
           <a:p>
@@ -4317,7 +4292,6 @@
           <a:lstStyle/>
           <a:p>
             <a:pPr algn="ctr"/>
-            <a:endParaRPr/>
           </a:p>
         </p:txBody>
       </p:sp>
@@ -4368,7 +4342,7 @@
               </a:defRPr>
             </a:pPr>
             <a:r>
-              <a:t>•  curl -s http://54.253.170.114/health  -&gt; Returns {"status": "healthy", "version": "1.0.0"}</a:t>
+              <a:t>•  curl -s http://3.104.55.68/health  -&gt; Returns {"status": "healthy", "version": "1.0.0"}</a:t>
             </a:r>
           </a:p>
           <a:p>
@@ -4384,7 +4358,7 @@
               </a:defRPr>
             </a:pPr>
             <a:r>
-              <a:t>•  curl -s http://54.253.170.114/api/info -&gt; Demonstrates round-robin hostname switching across replicas</a:t>
+              <a:t>•  curl -s http://3.104.55.68/api/info -&gt; Demonstrates round-robin hostname switching across replicas</a:t>
             </a:r>
           </a:p>
           <a:p>
@@ -4400,7 +4374,7 @@
               </a:defRPr>
             </a:pPr>
             <a:r>
-              <a:t>•  curl -s http://54.253.170.114/nginx-health -&gt; Confirms load balancer routing integrity</a:t>
+              <a:t>•  curl -s http://3.104.55.68/nginx-health -&gt; Confirms load balancer routing integrity</a:t>
             </a:r>
           </a:p>
         </p:txBody>
@@ -4447,7 +4421,6 @@
           <a:lstStyle/>
           <a:p>
             <a:pPr algn="ctr"/>
-            <a:endParaRPr/>
           </a:p>
         </p:txBody>
       </p:sp>
@@ -4577,7 +4550,6 @@
           <a:lstStyle/>
           <a:p>
             <a:pPr algn="ctr"/>
-            <a:endParaRPr/>
           </a:p>
         </p:txBody>
       </p:sp>
@@ -4628,7 +4600,7 @@
               </a:defRPr>
             </a:pPr>
             <a:r>
-              <a:t>•  ssh -i chamroeunsaran.pem ubuntu@54.253.170.114</a:t>
+              <a:t>•  ssh -i chamroeunsaran.pem ubuntu@3.104.55.68</a:t>
             </a:r>
           </a:p>
           <a:p>
@@ -4674,7 +4646,7 @@
 </file>
 
 <file path=ppt/slides/slide12.xml><?xml version="1.0" encoding="utf-8"?>
-<p:sld xmlns:a="http://schemas.openxmlformats.org/drawingml/2006/main" xmlns:r="http://schemas.openxmlformats.org/officeDocument/2006/relationships" xmlns:p="http://schemas.openxmlformats.org/presentationml/2006/main">
+<p:sld xmlns:a="http://schemas.openxmlformats.org/drawingml/2006/main" xmlns:p="http://schemas.openxmlformats.org/presentationml/2006/main" xmlns:r="http://schemas.openxmlformats.org/officeDocument/2006/relationships">
   <p:cSld>
     <p:spTree>
       <p:nvGrpSpPr>
@@ -4682,14 +4654,7 @@
         <p:cNvGrpSpPr/>
         <p:nvPr/>
       </p:nvGrpSpPr>
-      <p:grpSpPr>
-        <a:xfrm>
-          <a:off x="0" y="0"/>
-          <a:ext cx="0" cy="0"/>
-          <a:chOff x="0" y="0"/>
-          <a:chExt cx="0" cy="0"/>
-        </a:xfrm>
-      </p:grpSpPr>
+      <p:grpSpPr/>
       <p:sp>
         <p:nvSpPr>
           <p:cNvPr id="2" name="Rectangle 1"/>
@@ -4730,7 +4695,6 @@
           <a:lstStyle/>
           <a:p>
             <a:pPr algn="ctr"/>
-            <a:endParaRPr/>
           </a:p>
         </p:txBody>
       </p:sp>
@@ -4776,7 +4740,6 @@
           <a:lstStyle/>
           <a:p>
             <a:pPr algn="ctr"/>
-            <a:endParaRPr/>
           </a:p>
         </p:txBody>
       </p:sp>
@@ -4976,6 +4939,14 @@
           </a:p>
           <a:p>
             <a:br/>
+            <a:pPr algn="ctr">
+              <a:defRPr sz="1600" b="1">
+                <a:solidFill>
+                  <a:srgbClr val="0284C7"/>
+                </a:solidFill>
+                <a:latin typeface="Segoe UI"/>
+              </a:defRPr>
+            </a:pPr>
             <a:r>
               <a:t>Thank You!  —  Questions &amp; Discussion</a:t>
             </a:r>
@@ -4991,7 +4962,7 @@
 </file>
 
 <file path=ppt/slides/slide2.xml><?xml version="1.0" encoding="utf-8"?>
-<p:sld xmlns:a="http://schemas.openxmlformats.org/drawingml/2006/main" xmlns:r="http://schemas.openxmlformats.org/officeDocument/2006/relationships" xmlns:p="http://schemas.openxmlformats.org/presentationml/2006/main">
+<p:sld xmlns:a="http://schemas.openxmlformats.org/drawingml/2006/main" xmlns:p="http://schemas.openxmlformats.org/presentationml/2006/main" xmlns:r="http://schemas.openxmlformats.org/officeDocument/2006/relationships">
   <p:cSld>
     <p:spTree>
       <p:nvGrpSpPr>
@@ -4999,14 +4970,7 @@
         <p:cNvGrpSpPr/>
         <p:nvPr/>
       </p:nvGrpSpPr>
-      <p:grpSpPr>
-        <a:xfrm>
-          <a:off x="0" y="0"/>
-          <a:ext cx="0" cy="0"/>
-          <a:chOff x="0" y="0"/>
-          <a:chExt cx="0" cy="0"/>
-        </a:xfrm>
-      </p:grpSpPr>
+      <p:grpSpPr/>
       <p:sp>
         <p:nvSpPr>
           <p:cNvPr id="2" name="TextBox 1"/>
@@ -5121,7 +5085,6 @@
           <a:lstStyle/>
           <a:p>
             <a:pPr algn="ctr"/>
-            <a:endParaRPr/>
           </a:p>
         </p:txBody>
       </p:sp>
@@ -5167,7 +5130,6 @@
           <a:lstStyle/>
           <a:p>
             <a:pPr algn="ctr"/>
-            <a:endParaRPr/>
           </a:p>
         </p:txBody>
       </p:sp>
@@ -5313,7 +5275,6 @@
           <a:lstStyle/>
           <a:p>
             <a:pPr algn="ctr"/>
-            <a:endParaRPr/>
           </a:p>
         </p:txBody>
       </p:sp>
@@ -5459,7 +5420,6 @@
           <a:lstStyle/>
           <a:p>
             <a:pPr algn="ctr"/>
-            <a:endParaRPr/>
           </a:p>
         </p:txBody>
       </p:sp>
@@ -5605,7 +5565,6 @@
           <a:lstStyle/>
           <a:p>
             <a:pPr algn="ctr"/>
-            <a:endParaRPr/>
           </a:p>
         </p:txBody>
       </p:sp>
@@ -5718,7 +5677,7 @@
 </file>
 
 <file path=ppt/slides/slide3.xml><?xml version="1.0" encoding="utf-8"?>
-<p:sld xmlns:a="http://schemas.openxmlformats.org/drawingml/2006/main" xmlns:r="http://schemas.openxmlformats.org/officeDocument/2006/relationships" xmlns:p="http://schemas.openxmlformats.org/presentationml/2006/main">
+<p:sld xmlns:a="http://schemas.openxmlformats.org/drawingml/2006/main" xmlns:p="http://schemas.openxmlformats.org/presentationml/2006/main" xmlns:r="http://schemas.openxmlformats.org/officeDocument/2006/relationships">
   <p:cSld>
     <p:spTree>
       <p:nvGrpSpPr>
@@ -5726,14 +5685,7 @@
         <p:cNvGrpSpPr/>
         <p:nvPr/>
       </p:nvGrpSpPr>
-      <p:grpSpPr>
-        <a:xfrm>
-          <a:off x="0" y="0"/>
-          <a:ext cx="0" cy="0"/>
-          <a:chOff x="0" y="0"/>
-          <a:chExt cx="0" cy="0"/>
-        </a:xfrm>
-      </p:grpSpPr>
+      <p:grpSpPr/>
       <p:sp>
         <p:nvSpPr>
           <p:cNvPr id="2" name="TextBox 1"/>
@@ -5848,7 +5800,6 @@
           <a:lstStyle/>
           <a:p>
             <a:pPr algn="ctr"/>
-            <a:endParaRPr/>
           </a:p>
         </p:txBody>
       </p:sp>
@@ -5894,7 +5845,6 @@
           <a:lstStyle/>
           <a:p>
             <a:pPr algn="ctr"/>
-            <a:endParaRPr/>
           </a:p>
         </p:txBody>
       </p:sp>
@@ -6144,7 +6094,6 @@
           <a:lstStyle/>
           <a:p>
             <a:pPr algn="ctr"/>
-            <a:endParaRPr/>
           </a:p>
         </p:txBody>
       </p:sp>
@@ -6181,7 +6130,7 @@
 </file>
 
 <file path=ppt/slides/slide4.xml><?xml version="1.0" encoding="utf-8"?>
-<p:sld xmlns:a="http://schemas.openxmlformats.org/drawingml/2006/main" xmlns:r="http://schemas.openxmlformats.org/officeDocument/2006/relationships" xmlns:p="http://schemas.openxmlformats.org/presentationml/2006/main">
+<p:sld xmlns:a="http://schemas.openxmlformats.org/drawingml/2006/main" xmlns:p="http://schemas.openxmlformats.org/presentationml/2006/main" xmlns:r="http://schemas.openxmlformats.org/officeDocument/2006/relationships">
   <p:cSld>
     <p:spTree>
       <p:nvGrpSpPr>
@@ -6189,14 +6138,7 @@
         <p:cNvGrpSpPr/>
         <p:nvPr/>
       </p:nvGrpSpPr>
-      <p:grpSpPr>
-        <a:xfrm>
-          <a:off x="0" y="0"/>
-          <a:ext cx="0" cy="0"/>
-          <a:chOff x="0" y="0"/>
-          <a:chExt cx="0" cy="0"/>
-        </a:xfrm>
-      </p:grpSpPr>
+      <p:grpSpPr/>
       <p:sp>
         <p:nvSpPr>
           <p:cNvPr id="2" name="TextBox 1"/>
@@ -6311,7 +6253,6 @@
           <a:lstStyle/>
           <a:p>
             <a:pPr algn="ctr"/>
-            <a:endParaRPr/>
           </a:p>
         </p:txBody>
       </p:sp>
@@ -6357,7 +6298,6 @@
           <a:lstStyle/>
           <a:p>
             <a:pPr algn="ctr"/>
-            <a:endParaRPr/>
           </a:p>
         </p:txBody>
       </p:sp>
@@ -6559,7 +6499,6 @@
           <a:lstStyle/>
           <a:p>
             <a:pPr algn="ctr"/>
-            <a:endParaRPr/>
           </a:p>
         </p:txBody>
       </p:sp>
@@ -6596,7 +6535,7 @@
 </file>
 
 <file path=ppt/slides/slide5.xml><?xml version="1.0" encoding="utf-8"?>
-<p:sld xmlns:a="http://schemas.openxmlformats.org/drawingml/2006/main" xmlns:r="http://schemas.openxmlformats.org/officeDocument/2006/relationships" xmlns:p="http://schemas.openxmlformats.org/presentationml/2006/main">
+<p:sld xmlns:a="http://schemas.openxmlformats.org/drawingml/2006/main" xmlns:p="http://schemas.openxmlformats.org/presentationml/2006/main" xmlns:r="http://schemas.openxmlformats.org/officeDocument/2006/relationships">
   <p:cSld>
     <p:spTree>
       <p:nvGrpSpPr>
@@ -6604,14 +6543,7 @@
         <p:cNvGrpSpPr/>
         <p:nvPr/>
       </p:nvGrpSpPr>
-      <p:grpSpPr>
-        <a:xfrm>
-          <a:off x="0" y="0"/>
-          <a:ext cx="0" cy="0"/>
-          <a:chOff x="0" y="0"/>
-          <a:chExt cx="0" cy="0"/>
-        </a:xfrm>
-      </p:grpSpPr>
+      <p:grpSpPr/>
       <p:sp>
         <p:nvSpPr>
           <p:cNvPr id="2" name="TextBox 1"/>
@@ -6679,16 +6611,7 @@
               </a:defRPr>
             </a:pPr>
             <a:r>
-              <a:rPr dirty="0"/>
-              <a:t>Production </a:t>
-            </a:r>
-            <a:r>
-              <a:rPr dirty="0" err="1"/>
-              <a:t>Dockerfile</a:t>
-            </a:r>
-            <a:r>
-              <a:rPr dirty="0"/>
-              <a:t> &amp; Security Hardening</a:t>
+              <a:t>Production Dockerfile &amp; Security Hardening</a:t>
             </a:r>
           </a:p>
         </p:txBody>
@@ -6735,7 +6658,6 @@
           <a:lstStyle/>
           <a:p>
             <a:pPr algn="ctr"/>
-            <a:endParaRPr/>
           </a:p>
         </p:txBody>
       </p:sp>
@@ -6781,7 +6703,6 @@
           <a:lstStyle/>
           <a:p>
             <a:pPr algn="ctr"/>
-            <a:endParaRPr/>
           </a:p>
         </p:txBody>
       </p:sp>
@@ -6816,7 +6737,6 @@
               </a:defRPr>
             </a:pPr>
             <a:r>
-              <a:rPr dirty="0"/>
               <a:t>Containerization Standards</a:t>
             </a:r>
           </a:p>
@@ -6833,11 +6753,10 @@
               </a:defRPr>
             </a:pPr>
             <a:r>
-              <a:rPr dirty="0"/>
               <a:t>• Multi-Stage Build Pattern: </a:t>
             </a:r>
             <a:r>
-              <a:rPr b="0" dirty="0">
+              <a:rPr b="0">
                 <a:solidFill>
                   <a:srgbClr val="64748B"/>
                 </a:solidFill>
@@ -6858,64 +6777,15 @@
               </a:defRPr>
             </a:pPr>
             <a:r>
-              <a:rPr dirty="0"/>
               <a:t>• Non-Root Security Context: </a:t>
             </a:r>
             <a:r>
-              <a:rPr b="0" dirty="0">
+              <a:rPr b="0">
                 <a:solidFill>
                   <a:srgbClr val="64748B"/>
                 </a:solidFill>
               </a:rPr>
-              <a:t>Runs as dedicated </a:t>
-            </a:r>
-            <a:r>
-              <a:rPr b="0" dirty="0" err="1">
-                <a:solidFill>
-                  <a:srgbClr val="64748B"/>
-                </a:solidFill>
-              </a:rPr>
-              <a:t>appuser</a:t>
-            </a:r>
-            <a:r>
-              <a:rPr b="0" dirty="0">
-                <a:solidFill>
-                  <a:srgbClr val="64748B"/>
-                </a:solidFill>
-              </a:rPr>
-              <a:t> (UID 1000) with </a:t>
-            </a:r>
-            <a:r>
-              <a:rPr b="0" dirty="0" err="1">
-                <a:solidFill>
-                  <a:srgbClr val="64748B"/>
-                </a:solidFill>
-              </a:rPr>
-              <a:t>chown</a:t>
-            </a:r>
-            <a:r>
-              <a:rPr b="0" dirty="0">
-                <a:solidFill>
-                  <a:srgbClr val="64748B"/>
-                </a:solidFill>
-              </a:rPr>
-              <a:t> -R </a:t>
-            </a:r>
-            <a:r>
-              <a:rPr b="0" dirty="0" err="1">
-                <a:solidFill>
-                  <a:srgbClr val="64748B"/>
-                </a:solidFill>
-              </a:rPr>
-              <a:t>appuser:appuser</a:t>
-            </a:r>
-            <a:r>
-              <a:rPr b="0" dirty="0">
-                <a:solidFill>
-                  <a:srgbClr val="64748B"/>
-                </a:solidFill>
-              </a:rPr>
-              <a:t> /app to mitigate container breakout risks.</a:t>
+              <a:t>Runs as dedicated appuser (UID 1000) with chown -R appuser:appuser /app to mitigate container breakout risks.</a:t>
             </a:r>
           </a:p>
           <a:p>
@@ -6931,19 +6801,10 @@
               </a:defRPr>
             </a:pPr>
             <a:r>
-              <a:rPr dirty="0"/>
-              <a:t>• Container </a:t>
-            </a:r>
-            <a:r>
-              <a:rPr dirty="0" err="1"/>
-              <a:t>Healthcheck</a:t>
-            </a:r>
-            <a:r>
-              <a:rPr dirty="0"/>
-              <a:t>: </a:t>
-            </a:r>
-            <a:r>
-              <a:rPr b="0" dirty="0">
+              <a:t>• Container Healthcheck: </a:t>
+            </a:r>
+            <a:r>
+              <a:rPr b="0">
                 <a:solidFill>
                   <a:srgbClr val="64748B"/>
                 </a:solidFill>
@@ -6964,32 +6825,15 @@
               </a:defRPr>
             </a:pPr>
             <a:r>
-              <a:rPr dirty="0"/>
               <a:t>• Local Multi-Service Compose: </a:t>
             </a:r>
             <a:r>
-              <a:rPr b="0" dirty="0">
+              <a:rPr b="0">
                 <a:solidFill>
                   <a:srgbClr val="64748B"/>
                 </a:solidFill>
               </a:rPr>
-              <a:t>docker-</a:t>
-            </a:r>
-            <a:r>
-              <a:rPr b="0" dirty="0" err="1">
-                <a:solidFill>
-                  <a:srgbClr val="64748B"/>
-                </a:solidFill>
-              </a:rPr>
-              <a:t>compose.yml</a:t>
-            </a:r>
-            <a:r>
-              <a:rPr b="0" dirty="0">
-                <a:solidFill>
-                  <a:srgbClr val="64748B"/>
-                </a:solidFill>
-              </a:rPr>
-              <a:t> defines local developer environment with web and nginx services sharing a bridge network.</a:t>
+              <a:t>docker-compose.yml defines local developer environment with web and nginx services sharing a bridge network.</a:t>
             </a:r>
           </a:p>
           <a:p>
@@ -7005,32 +6849,15 @@
               </a:defRPr>
             </a:pPr>
             <a:r>
-              <a:rPr dirty="0"/>
               <a:t>• Minimal Image Footprint: </a:t>
             </a:r>
             <a:r>
-              <a:rPr b="0" dirty="0">
+              <a:rPr b="0">
                 <a:solidFill>
                   <a:srgbClr val="64748B"/>
                 </a:solidFill>
               </a:rPr>
-              <a:t>Utilizes .</a:t>
-            </a:r>
-            <a:r>
-              <a:rPr b="0" dirty="0" err="1">
-                <a:solidFill>
-                  <a:srgbClr val="64748B"/>
-                </a:solidFill>
-              </a:rPr>
-              <a:t>dockerignore</a:t>
-            </a:r>
-            <a:r>
-              <a:rPr b="0" dirty="0">
-                <a:solidFill>
-                  <a:srgbClr val="64748B"/>
-                </a:solidFill>
-              </a:rPr>
-              <a:t> to strip caches, git history, and secrets, reducing attack surface and pull latency.</a:t>
+              <a:t>Utilizes .dockerignore to strip caches, git history, and secrets, reducing attack surface and pull latency.</a:t>
             </a:r>
           </a:p>
         </p:txBody>
@@ -7077,7 +6904,6 @@
           <a:lstStyle/>
           <a:p>
             <a:pPr algn="ctr"/>
-            <a:endParaRPr/>
           </a:p>
         </p:txBody>
       </p:sp>
@@ -7114,7 +6940,7 @@
 </file>
 
 <file path=ppt/slides/slide6.xml><?xml version="1.0" encoding="utf-8"?>
-<p:sld xmlns:a="http://schemas.openxmlformats.org/drawingml/2006/main" xmlns:r="http://schemas.openxmlformats.org/officeDocument/2006/relationships" xmlns:p="http://schemas.openxmlformats.org/presentationml/2006/main">
+<p:sld xmlns:a="http://schemas.openxmlformats.org/drawingml/2006/main" xmlns:p="http://schemas.openxmlformats.org/presentationml/2006/main" xmlns:r="http://schemas.openxmlformats.org/officeDocument/2006/relationships">
   <p:cSld>
     <p:spTree>
       <p:nvGrpSpPr>
@@ -7122,14 +6948,7 @@
         <p:cNvGrpSpPr/>
         <p:nvPr/>
       </p:nvGrpSpPr>
-      <p:grpSpPr>
-        <a:xfrm>
-          <a:off x="0" y="0"/>
-          <a:ext cx="0" cy="0"/>
-          <a:chOff x="0" y="0"/>
-          <a:chExt cx="0" cy="0"/>
-        </a:xfrm>
-      </p:grpSpPr>
+      <p:grpSpPr/>
       <p:sp>
         <p:nvSpPr>
           <p:cNvPr id="2" name="TextBox 1"/>
@@ -7244,7 +7063,6 @@
           <a:lstStyle/>
           <a:p>
             <a:pPr algn="ctr"/>
-            <a:endParaRPr/>
           </a:p>
         </p:txBody>
       </p:sp>
@@ -7290,7 +7108,6 @@
           <a:lstStyle/>
           <a:p>
             <a:pPr algn="ctr"/>
-            <a:endParaRPr/>
           </a:p>
         </p:txBody>
       </p:sp>
@@ -7492,19 +7309,12 @@
           <a:lstStyle/>
           <a:p>
             <a:pPr algn="ctr"/>
-            <a:endParaRPr/>
           </a:p>
         </p:txBody>
       </p:sp>
       <p:pic>
         <p:nvPicPr>
-          <p:cNvPr id="10" name="Picture 9">
-            <a:extLst>
-              <a:ext uri="{FF2B5EF4-FFF2-40B4-BE49-F238E27FC236}">
-                <a16:creationId xmlns:a16="http://schemas.microsoft.com/office/drawing/2014/main" id="{20293E02-B906-278D-D238-340C9A6A7DD4}"/>
-              </a:ext>
-            </a:extLst>
-          </p:cNvPr>
+          <p:cNvPr id="8" name="Picture 7" descr="jenkins_build_success_live.png"/>
           <p:cNvPicPr>
             <a:picLocks noChangeAspect="1"/>
           </p:cNvPicPr>
@@ -7518,8 +7328,8 @@
         </p:blipFill>
         <p:spPr>
           <a:xfrm>
-            <a:off x="5760720" y="2280719"/>
-            <a:ext cx="5669280" cy="2931361"/>
+            <a:off x="5897880" y="1874519"/>
+            <a:ext cx="5394960" cy="2355026"/>
           </a:xfrm>
           <a:prstGeom prst="rect">
             <a:avLst/>
@@ -7535,7 +7345,7 @@
 </file>
 
 <file path=ppt/slides/slide7.xml><?xml version="1.0" encoding="utf-8"?>
-<p:sld xmlns:a="http://schemas.openxmlformats.org/drawingml/2006/main" xmlns:r="http://schemas.openxmlformats.org/officeDocument/2006/relationships" xmlns:p="http://schemas.openxmlformats.org/presentationml/2006/main">
+<p:sld xmlns:a="http://schemas.openxmlformats.org/drawingml/2006/main" xmlns:p="http://schemas.openxmlformats.org/presentationml/2006/main" xmlns:r="http://schemas.openxmlformats.org/officeDocument/2006/relationships">
   <p:cSld>
     <p:spTree>
       <p:nvGrpSpPr>
@@ -7543,14 +7353,7 @@
         <p:cNvGrpSpPr/>
         <p:nvPr/>
       </p:nvGrpSpPr>
-      <p:grpSpPr>
-        <a:xfrm>
-          <a:off x="0" y="0"/>
-          <a:ext cx="0" cy="0"/>
-          <a:chOff x="0" y="0"/>
-          <a:chExt cx="0" cy="0"/>
-        </a:xfrm>
-      </p:grpSpPr>
+      <p:grpSpPr/>
       <p:sp>
         <p:nvSpPr>
           <p:cNvPr id="2" name="TextBox 1"/>
@@ -7665,7 +7468,6 @@
           <a:lstStyle/>
           <a:p>
             <a:pPr algn="ctr"/>
-            <a:endParaRPr/>
           </a:p>
         </p:txBody>
       </p:sp>
@@ -7711,7 +7513,6 @@
           <a:lstStyle/>
           <a:p>
             <a:pPr algn="ctr"/>
-            <a:endParaRPr/>
           </a:p>
         </p:txBody>
       </p:sp>
@@ -7913,7 +7714,6 @@
           <a:lstStyle/>
           <a:p>
             <a:pPr algn="ctr"/>
-            <a:endParaRPr/>
           </a:p>
         </p:txBody>
       </p:sp>
@@ -7933,38 +7733,8 @@
         </p:blipFill>
         <p:spPr>
           <a:xfrm>
-            <a:off x="5897880" y="584835"/>
+            <a:off x="6080760" y="2011680"/>
             <a:ext cx="5212080" cy="3231490"/>
-          </a:xfrm>
-          <a:prstGeom prst="rect">
-            <a:avLst/>
-          </a:prstGeom>
-        </p:spPr>
-      </p:pic>
-      <p:pic>
-        <p:nvPicPr>
-          <p:cNvPr id="10" name="Picture 9">
-            <a:extLst>
-              <a:ext uri="{FF2B5EF4-FFF2-40B4-BE49-F238E27FC236}">
-                <a16:creationId xmlns:a16="http://schemas.microsoft.com/office/drawing/2014/main" id="{DEB5341B-1C71-6C95-AD6E-3710A753F23A}"/>
-              </a:ext>
-            </a:extLst>
-          </p:cNvPr>
-          <p:cNvPicPr>
-            <a:picLocks noChangeAspect="1"/>
-          </p:cNvPicPr>
-          <p:nvPr/>
-        </p:nvPicPr>
-        <p:blipFill>
-          <a:blip r:embed="rId3"/>
-          <a:stretch>
-            <a:fillRect/>
-          </a:stretch>
-        </p:blipFill>
-        <p:spPr>
-          <a:xfrm>
-            <a:off x="1643434" y="3977640"/>
-            <a:ext cx="8326012" cy="1333686"/>
           </a:xfrm>
           <a:prstGeom prst="rect">
             <a:avLst/>
@@ -7980,7 +7750,7 @@
 </file>
 
 <file path=ppt/slides/slide8.xml><?xml version="1.0" encoding="utf-8"?>
-<p:sld xmlns:a="http://schemas.openxmlformats.org/drawingml/2006/main" xmlns:r="http://schemas.openxmlformats.org/officeDocument/2006/relationships" xmlns:p="http://schemas.openxmlformats.org/presentationml/2006/main">
+<p:sld xmlns:a="http://schemas.openxmlformats.org/drawingml/2006/main" xmlns:p="http://schemas.openxmlformats.org/presentationml/2006/main" xmlns:r="http://schemas.openxmlformats.org/officeDocument/2006/relationships">
   <p:cSld>
     <p:spTree>
       <p:nvGrpSpPr>
@@ -7988,14 +7758,7 @@
         <p:cNvGrpSpPr/>
         <p:nvPr/>
       </p:nvGrpSpPr>
-      <p:grpSpPr>
-        <a:xfrm>
-          <a:off x="0" y="0"/>
-          <a:ext cx="0" cy="0"/>
-          <a:chOff x="0" y="0"/>
-          <a:chExt cx="0" cy="0"/>
-        </a:xfrm>
-      </p:grpSpPr>
+      <p:grpSpPr/>
       <p:sp>
         <p:nvSpPr>
           <p:cNvPr id="2" name="TextBox 1"/>
@@ -8110,7 +7873,6 @@
           <a:lstStyle/>
           <a:p>
             <a:pPr algn="ctr"/>
-            <a:endParaRPr/>
           </a:p>
         </p:txBody>
       </p:sp>
@@ -8156,7 +7918,6 @@
           <a:lstStyle/>
           <a:p>
             <a:pPr algn="ctr"/>
-            <a:endParaRPr/>
           </a:p>
         </p:txBody>
       </p:sp>
@@ -8382,7 +8143,6 @@
           <a:lstStyle/>
           <a:p>
             <a:pPr algn="ctr"/>
-            <a:endParaRPr/>
           </a:p>
         </p:txBody>
       </p:sp>
@@ -8419,7 +8179,7 @@
 </file>
 
 <file path=ppt/slides/slide9.xml><?xml version="1.0" encoding="utf-8"?>
-<p:sld xmlns:a="http://schemas.openxmlformats.org/drawingml/2006/main" xmlns:r="http://schemas.openxmlformats.org/officeDocument/2006/relationships" xmlns:p="http://schemas.openxmlformats.org/presentationml/2006/main">
+<p:sld xmlns:a="http://schemas.openxmlformats.org/drawingml/2006/main" xmlns:p="http://schemas.openxmlformats.org/presentationml/2006/main" xmlns:r="http://schemas.openxmlformats.org/officeDocument/2006/relationships">
   <p:cSld>
     <p:spTree>
       <p:nvGrpSpPr>
@@ -8427,14 +8187,7 @@
         <p:cNvGrpSpPr/>
         <p:nvPr/>
       </p:nvGrpSpPr>
-      <p:grpSpPr>
-        <a:xfrm>
-          <a:off x="0" y="0"/>
-          <a:ext cx="0" cy="0"/>
-          <a:chOff x="0" y="0"/>
-          <a:chExt cx="0" cy="0"/>
-        </a:xfrm>
-      </p:grpSpPr>
+      <p:grpSpPr/>
       <p:sp>
         <p:nvSpPr>
           <p:cNvPr id="2" name="TextBox 1"/>
@@ -8549,7 +8302,6 @@
           <a:lstStyle/>
           <a:p>
             <a:pPr algn="ctr"/>
-            <a:endParaRPr/>
           </a:p>
         </p:txBody>
       </p:sp>
@@ -8595,7 +8347,6 @@
           <a:lstStyle/>
           <a:p>
             <a:pPr algn="ctr"/>
-            <a:endParaRPr/>
           </a:p>
         </p:txBody>
       </p:sp>
@@ -8797,19 +8548,12 @@
           <a:lstStyle/>
           <a:p>
             <a:pPr algn="ctr"/>
-            <a:endParaRPr/>
           </a:p>
         </p:txBody>
       </p:sp>
       <p:pic>
         <p:nvPicPr>
-          <p:cNvPr id="10" name="Picture 9">
-            <a:extLst>
-              <a:ext uri="{FF2B5EF4-FFF2-40B4-BE49-F238E27FC236}">
-                <a16:creationId xmlns:a16="http://schemas.microsoft.com/office/drawing/2014/main" id="{AE7A94BB-38F3-BA23-E39F-09AE0562E8CE}"/>
-              </a:ext>
-            </a:extLst>
-          </p:cNvPr>
+          <p:cNvPr id="8" name="Picture 7" descr="telegram_notification.png"/>
           <p:cNvPicPr>
             <a:picLocks noChangeAspect="1"/>
           </p:cNvPicPr>
@@ -8823,8 +8567,8 @@
         </p:blipFill>
         <p:spPr>
           <a:xfrm>
-            <a:off x="6511400" y="2209800"/>
-            <a:ext cx="4071143" cy="3164205"/>
+            <a:off x="6080760" y="2011680"/>
+            <a:ext cx="5212080" cy="4039362"/>
           </a:xfrm>
           <a:prstGeom prst="rect">
             <a:avLst/>

</xml_diff>

<commit_message>
fix: update cluster public IPs after EC2 restart (manager: 16.178.178.44, workers: 3.107.55.229, 3.27.26.70)
</commit_message>
<xml_diff>
--- a/Assignment.pptx
+++ b/Assignment.pptx
@@ -3350,7 +3350,7 @@
               </a:defRPr>
             </a:pPr>
             <a:r>
-              <a:t>Verification: Jenkins Pipeline #4 Passed  |  Live Cluster IP: 3.104.55.68  |  October 2026</a:t>
+              <a:t>Verification: Jenkins Pipeline #4 Passed  |  Live Cluster IP: 16.178.178.44  |  October 2026</a:t>
             </a:r>
           </a:p>
         </p:txBody>
@@ -4213,7 +4213,7 @@
               </a:defRPr>
             </a:pPr>
             <a:r>
-              <a:t>•  Open browser: http://3.104.55.68</a:t>
+              <a:t>•  Open browser: http://16.178.178.44</a:t>
             </a:r>
           </a:p>
           <a:p>
@@ -4342,7 +4342,7 @@
               </a:defRPr>
             </a:pPr>
             <a:r>
-              <a:t>•  curl -s http://3.104.55.68/health  -&gt; Returns {"status": "healthy", "version": "1.0.0"}</a:t>
+              <a:t>•  curl -s http://16.178.178.44/health  -&gt; Returns {"status": "healthy", "version": "1.0.0"}</a:t>
             </a:r>
           </a:p>
           <a:p>
@@ -4358,7 +4358,7 @@
               </a:defRPr>
             </a:pPr>
             <a:r>
-              <a:t>•  curl -s http://3.104.55.68/api/info -&gt; Demonstrates round-robin hostname switching across replicas</a:t>
+              <a:t>•  curl -s http://16.178.178.44/api/info -&gt; Demonstrates round-robin hostname switching across replicas</a:t>
             </a:r>
           </a:p>
           <a:p>
@@ -4374,7 +4374,7 @@
               </a:defRPr>
             </a:pPr>
             <a:r>
-              <a:t>•  curl -s http://3.104.55.68/nginx-health -&gt; Confirms load balancer routing integrity</a:t>
+              <a:t>•  curl -s http://16.178.178.44/nginx-health -&gt; Confirms load balancer routing integrity</a:t>
             </a:r>
           </a:p>
         </p:txBody>
@@ -4600,7 +4600,7 @@
               </a:defRPr>
             </a:pPr>
             <a:r>
-              <a:t>•  ssh -i chamroeunsaran.pem ubuntu@3.104.55.68</a:t>
+              <a:t>•  ssh -i chamroeunsaran.pem ubuntu@16.178.178.44</a:t>
             </a:r>
           </a:p>
           <a:p>
@@ -6519,7 +6519,7 @@
         <p:spPr>
           <a:xfrm>
             <a:off x="6080760" y="1828800"/>
-            <a:ext cx="5212080" cy="4065422"/>
+            <a:ext cx="5212080" cy="4084375"/>
           </a:xfrm>
           <a:prstGeom prst="rect">
             <a:avLst/>

</xml_diff>